<commit_message>
Add two-member Project Team section (Mubashar Ali + Momina Ali) to DocCompressor poster
Co-authored-by: mubasharali24428-crypto <245346541+mubasharali24428-crypto@users.noreply.github.com>
</commit_message>
<xml_diff>
--- a/DocCompressor_Poster.pptx
+++ b/DocCompressor_Poster.pptx
@@ -4363,8 +4363,8 @@
         </p:nvSpPr>
         <p:spPr>
           <a:xfrm>
-            <a:off x="585216" y="8769096"/>
-            <a:ext cx="14442948" cy="7132320"/>
+            <a:off x="585216" y="8723376"/>
+            <a:ext cx="29269944" cy="4754880"/>
           </a:xfrm>
           <a:prstGeom prst="rect">
             <a:avLst/>
@@ -4406,8 +4406,8 @@
         </p:nvSpPr>
         <p:spPr>
           <a:xfrm>
-            <a:off x="502920" y="8686800"/>
-            <a:ext cx="14442948" cy="7132320"/>
+            <a:off x="502920" y="8641080"/>
+            <a:ext cx="29269944" cy="4754880"/>
           </a:xfrm>
           <a:prstGeom prst="rect">
             <a:avLst/>
@@ -4451,8 +4451,8 @@
         </p:nvSpPr>
         <p:spPr>
           <a:xfrm>
-            <a:off x="502920" y="8686800"/>
-            <a:ext cx="14442948" cy="777240"/>
+            <a:off x="502920" y="8641080"/>
+            <a:ext cx="29269944" cy="777240"/>
           </a:xfrm>
           <a:prstGeom prst="rect">
             <a:avLst/>
@@ -4494,8 +4494,8 @@
         </p:nvSpPr>
         <p:spPr>
           <a:xfrm>
-            <a:off x="502920" y="9464040"/>
-            <a:ext cx="91440" cy="6355080"/>
+            <a:off x="502920" y="9418320"/>
+            <a:ext cx="91440" cy="3977640"/>
           </a:xfrm>
           <a:prstGeom prst="rect">
             <a:avLst/>
@@ -4537,8 +4537,8 @@
         </p:nvSpPr>
         <p:spPr>
           <a:xfrm>
-            <a:off x="704088" y="8759952"/>
-            <a:ext cx="14122908" cy="722376"/>
+            <a:off x="704088" y="8714232"/>
+            <a:ext cx="28949904" cy="722376"/>
           </a:xfrm>
           <a:prstGeom prst="rect">
             <a:avLst/>
@@ -4559,6 +4559,937 @@
                 </a:solidFill>
                 <a:latin typeface="Calibri"/>
               </a:rPr>
+              <a:t>Project Team</a:t>
+            </a:r>
+          </a:p>
+        </p:txBody>
+      </p:sp>
+      <p:sp>
+        <p:nvSpPr>
+          <p:cNvPr id="40" name="Rectangle 39"/>
+          <p:cNvSpPr/>
+          <p:nvPr/>
+        </p:nvSpPr>
+        <p:spPr>
+          <a:xfrm>
+            <a:off x="3342132" y="9528048"/>
+            <a:ext cx="11887200" cy="3749040"/>
+          </a:xfrm>
+          <a:prstGeom prst="rect">
+            <a:avLst/>
+          </a:prstGeom>
+          <a:solidFill>
+            <a:srgbClr val="E3F2FD"/>
+          </a:solidFill>
+          <a:ln w="19050">
+            <a:solidFill>
+              <a:srgbClr val="BBDEFB"/>
+            </a:solidFill>
+          </a:ln>
+        </p:spPr>
+        <p:style>
+          <a:lnRef idx="1">
+            <a:schemeClr val="accent1"/>
+          </a:lnRef>
+          <a:fillRef idx="3">
+            <a:schemeClr val="accent1"/>
+          </a:fillRef>
+          <a:effectRef idx="2">
+            <a:schemeClr val="accent1"/>
+          </a:effectRef>
+          <a:fontRef idx="minor">
+            <a:schemeClr val="lt1"/>
+          </a:fontRef>
+        </p:style>
+        <p:txBody>
+          <a:bodyPr rtlCol="0" anchor="ctr"/>
+          <a:lstStyle/>
+          <a:p>
+            <a:pPr algn="ctr"/>
+          </a:p>
+        </p:txBody>
+      </p:sp>
+      <p:sp>
+        <p:nvSpPr>
+          <p:cNvPr id="41" name="Rectangle 40"/>
+          <p:cNvSpPr/>
+          <p:nvPr/>
+        </p:nvSpPr>
+        <p:spPr>
+          <a:xfrm>
+            <a:off x="7895844" y="9582912"/>
+            <a:ext cx="2779776" cy="2779776"/>
+          </a:xfrm>
+          <a:prstGeom prst="rect">
+            <a:avLst/>
+          </a:prstGeom>
+          <a:solidFill>
+            <a:srgbClr val="FFFFFF"/>
+          </a:solidFill>
+          <a:ln w="38100">
+            <a:solidFill>
+              <a:srgbClr val="1565C0"/>
+            </a:solidFill>
+          </a:ln>
+        </p:spPr>
+        <p:style>
+          <a:lnRef idx="1">
+            <a:schemeClr val="accent1"/>
+          </a:lnRef>
+          <a:fillRef idx="3">
+            <a:schemeClr val="accent1"/>
+          </a:fillRef>
+          <a:effectRef idx="2">
+            <a:schemeClr val="accent1"/>
+          </a:effectRef>
+          <a:fontRef idx="minor">
+            <a:schemeClr val="lt1"/>
+          </a:fontRef>
+        </p:style>
+        <p:txBody>
+          <a:bodyPr rtlCol="0" anchor="ctr"/>
+          <a:lstStyle/>
+          <a:p>
+            <a:pPr algn="ctr"/>
+          </a:p>
+        </p:txBody>
+      </p:sp>
+      <p:sp>
+        <p:nvSpPr>
+          <p:cNvPr id="42" name="Oval 41"/>
+          <p:cNvSpPr/>
+          <p:nvPr/>
+        </p:nvSpPr>
+        <p:spPr>
+          <a:xfrm>
+            <a:off x="7895844" y="9582912"/>
+            <a:ext cx="2779776" cy="2779776"/>
+          </a:xfrm>
+          <a:prstGeom prst="ellipse">
+            <a:avLst/>
+          </a:prstGeom>
+          <a:solidFill>
+            <a:srgbClr val="FFFFFF"/>
+          </a:solidFill>
+          <a:ln w="50800">
+            <a:solidFill>
+              <a:srgbClr val="1565C0"/>
+            </a:solidFill>
+          </a:ln>
+        </p:spPr>
+        <p:style>
+          <a:lnRef idx="1">
+            <a:schemeClr val="accent1"/>
+          </a:lnRef>
+          <a:fillRef idx="3">
+            <a:schemeClr val="accent1"/>
+          </a:fillRef>
+          <a:effectRef idx="2">
+            <a:schemeClr val="accent1"/>
+          </a:effectRef>
+          <a:fontRef idx="minor">
+            <a:schemeClr val="lt1"/>
+          </a:fontRef>
+        </p:style>
+        <p:txBody>
+          <a:bodyPr rtlCol="0" anchor="ctr"/>
+          <a:lstStyle/>
+          <a:p>
+            <a:pPr algn="ctr"/>
+          </a:p>
+        </p:txBody>
+      </p:sp>
+      <p:sp>
+        <p:nvSpPr>
+          <p:cNvPr id="43" name="Oval 42"/>
+          <p:cNvSpPr/>
+          <p:nvPr/>
+        </p:nvSpPr>
+        <p:spPr>
+          <a:xfrm>
+            <a:off x="8005572" y="9692640"/>
+            <a:ext cx="2560320" cy="2560320"/>
+          </a:xfrm>
+          <a:prstGeom prst="ellipse">
+            <a:avLst/>
+          </a:prstGeom>
+          <a:solidFill>
+            <a:srgbClr val="0D47A1"/>
+          </a:solidFill>
+          <a:ln>
+            <a:noFill/>
+          </a:ln>
+        </p:spPr>
+        <p:style>
+          <a:lnRef idx="1">
+            <a:schemeClr val="accent1"/>
+          </a:lnRef>
+          <a:fillRef idx="3">
+            <a:schemeClr val="accent1"/>
+          </a:fillRef>
+          <a:effectRef idx="2">
+            <a:schemeClr val="accent1"/>
+          </a:effectRef>
+          <a:fontRef idx="minor">
+            <a:schemeClr val="lt1"/>
+          </a:fontRef>
+        </p:style>
+        <p:txBody>
+          <a:bodyPr rtlCol="0" anchor="ctr"/>
+          <a:lstStyle/>
+          <a:p>
+            <a:pPr algn="ctr"/>
+          </a:p>
+        </p:txBody>
+      </p:sp>
+      <p:sp>
+        <p:nvSpPr>
+          <p:cNvPr id="44" name="TextBox 43"/>
+          <p:cNvSpPr txBox="1"/>
+          <p:nvPr/>
+        </p:nvSpPr>
+        <p:spPr>
+          <a:xfrm>
+            <a:off x="8737092" y="10332720"/>
+            <a:ext cx="1097280" cy="1097280"/>
+          </a:xfrm>
+          <a:prstGeom prst="rect">
+            <a:avLst/>
+          </a:prstGeom>
+          <a:noFill/>
+        </p:spPr>
+        <p:txBody>
+          <a:bodyPr wrap="square">
+            <a:spAutoFit/>
+          </a:bodyPr>
+          <a:lstStyle/>
+          <a:p>
+            <a:pPr algn="ctr"/>
+            <a:r>
+              <a:rPr sz="6800" b="1" i="0">
+                <a:solidFill>
+                  <a:srgbClr val="FFFFFF"/>
+                </a:solidFill>
+                <a:latin typeface="Calibri"/>
+              </a:rPr>
+              <a:t>MA</a:t>
+            </a:r>
+          </a:p>
+        </p:txBody>
+      </p:sp>
+      <p:sp>
+        <p:nvSpPr>
+          <p:cNvPr id="45" name="TextBox 44"/>
+          <p:cNvSpPr txBox="1"/>
+          <p:nvPr/>
+        </p:nvSpPr>
+        <p:spPr>
+          <a:xfrm>
+            <a:off x="3342132" y="12344400"/>
+            <a:ext cx="11887200" cy="384048"/>
+          </a:xfrm>
+          <a:prstGeom prst="rect">
+            <a:avLst/>
+          </a:prstGeom>
+          <a:noFill/>
+        </p:spPr>
+        <p:txBody>
+          <a:bodyPr wrap="square">
+            <a:spAutoFit/>
+          </a:bodyPr>
+          <a:lstStyle/>
+          <a:p>
+            <a:pPr algn="ctr"/>
+            <a:r>
+              <a:rPr sz="2200" b="0" i="1">
+                <a:solidFill>
+                  <a:srgbClr val="757575"/>
+                </a:solidFill>
+                <a:latin typeface="Calibri"/>
+              </a:rPr>
+              <a:t>[ Replace with photo ]</a:t>
+            </a:r>
+          </a:p>
+        </p:txBody>
+      </p:sp>
+      <p:sp>
+        <p:nvSpPr>
+          <p:cNvPr id="46" name="TextBox 45"/>
+          <p:cNvSpPr txBox="1"/>
+          <p:nvPr/>
+        </p:nvSpPr>
+        <p:spPr>
+          <a:xfrm>
+            <a:off x="3342132" y="12765024"/>
+            <a:ext cx="11887200" cy="731520"/>
+          </a:xfrm>
+          <a:prstGeom prst="rect">
+            <a:avLst/>
+          </a:prstGeom>
+          <a:noFill/>
+        </p:spPr>
+        <p:txBody>
+          <a:bodyPr wrap="square">
+            <a:spAutoFit/>
+          </a:bodyPr>
+          <a:lstStyle/>
+          <a:p>
+            <a:pPr algn="ctr"/>
+            <a:r>
+              <a:rPr sz="4600" b="1" i="0">
+                <a:solidFill>
+                  <a:srgbClr val="0D47A1"/>
+                </a:solidFill>
+                <a:latin typeface="Calibri"/>
+              </a:rPr>
+              <a:t>Mubashar Ali</a:t>
+            </a:r>
+          </a:p>
+        </p:txBody>
+      </p:sp>
+      <p:sp>
+        <p:nvSpPr>
+          <p:cNvPr id="47" name="TextBox 46"/>
+          <p:cNvSpPr txBox="1"/>
+          <p:nvPr/>
+        </p:nvSpPr>
+        <p:spPr>
+          <a:xfrm>
+            <a:off x="3342132" y="13514832"/>
+            <a:ext cx="11887200" cy="502920"/>
+          </a:xfrm>
+          <a:prstGeom prst="rect">
+            <a:avLst/>
+          </a:prstGeom>
+          <a:noFill/>
+        </p:spPr>
+        <p:txBody>
+          <a:bodyPr wrap="square">
+            <a:spAutoFit/>
+          </a:bodyPr>
+          <a:lstStyle/>
+          <a:p>
+            <a:pPr algn="ctr"/>
+            <a:r>
+              <a:rPr sz="2800" b="0" i="1">
+                <a:solidFill>
+                  <a:srgbClr val="1565C0"/>
+                </a:solidFill>
+                <a:latin typeface="Calibri"/>
+              </a:rPr>
+              <a:t>Developer  ·  BS Robotics &amp; AI</a:t>
+            </a:r>
+          </a:p>
+        </p:txBody>
+      </p:sp>
+      <p:sp>
+        <p:nvSpPr>
+          <p:cNvPr id="48" name="Rectangle 47"/>
+          <p:cNvSpPr/>
+          <p:nvPr/>
+        </p:nvSpPr>
+        <p:spPr>
+          <a:xfrm>
+            <a:off x="7914132" y="13423392"/>
+            <a:ext cx="2743200" cy="45720"/>
+          </a:xfrm>
+          <a:prstGeom prst="rect">
+            <a:avLst/>
+          </a:prstGeom>
+          <a:solidFill>
+            <a:srgbClr val="42A5F5"/>
+          </a:solidFill>
+          <a:ln>
+            <a:noFill/>
+          </a:ln>
+        </p:spPr>
+        <p:style>
+          <a:lnRef idx="1">
+            <a:schemeClr val="accent1"/>
+          </a:lnRef>
+          <a:fillRef idx="3">
+            <a:schemeClr val="accent1"/>
+          </a:fillRef>
+          <a:effectRef idx="2">
+            <a:schemeClr val="accent1"/>
+          </a:effectRef>
+          <a:fontRef idx="minor">
+            <a:schemeClr val="lt1"/>
+          </a:fontRef>
+        </p:style>
+        <p:txBody>
+          <a:bodyPr rtlCol="0" anchor="ctr"/>
+          <a:lstStyle/>
+          <a:p>
+            <a:pPr algn="ctr"/>
+          </a:p>
+        </p:txBody>
+      </p:sp>
+      <p:sp>
+        <p:nvSpPr>
+          <p:cNvPr id="49" name="Rectangle 48"/>
+          <p:cNvSpPr/>
+          <p:nvPr/>
+        </p:nvSpPr>
+        <p:spPr>
+          <a:xfrm>
+            <a:off x="17885664" y="9528048"/>
+            <a:ext cx="11887200" cy="3749040"/>
+          </a:xfrm>
+          <a:prstGeom prst="rect">
+            <a:avLst/>
+          </a:prstGeom>
+          <a:solidFill>
+            <a:srgbClr val="E3F2FD"/>
+          </a:solidFill>
+          <a:ln w="19050">
+            <a:solidFill>
+              <a:srgbClr val="BBDEFB"/>
+            </a:solidFill>
+          </a:ln>
+        </p:spPr>
+        <p:style>
+          <a:lnRef idx="1">
+            <a:schemeClr val="accent1"/>
+          </a:lnRef>
+          <a:fillRef idx="3">
+            <a:schemeClr val="accent1"/>
+          </a:fillRef>
+          <a:effectRef idx="2">
+            <a:schemeClr val="accent1"/>
+          </a:effectRef>
+          <a:fontRef idx="minor">
+            <a:schemeClr val="lt1"/>
+          </a:fontRef>
+        </p:style>
+        <p:txBody>
+          <a:bodyPr rtlCol="0" anchor="ctr"/>
+          <a:lstStyle/>
+          <a:p>
+            <a:pPr algn="ctr"/>
+          </a:p>
+        </p:txBody>
+      </p:sp>
+      <p:sp>
+        <p:nvSpPr>
+          <p:cNvPr id="50" name="Rectangle 49"/>
+          <p:cNvSpPr/>
+          <p:nvPr/>
+        </p:nvSpPr>
+        <p:spPr>
+          <a:xfrm>
+            <a:off x="22439376" y="9582912"/>
+            <a:ext cx="2779776" cy="2779776"/>
+          </a:xfrm>
+          <a:prstGeom prst="rect">
+            <a:avLst/>
+          </a:prstGeom>
+          <a:solidFill>
+            <a:srgbClr val="FFFFFF"/>
+          </a:solidFill>
+          <a:ln w="38100">
+            <a:solidFill>
+              <a:srgbClr val="1565C0"/>
+            </a:solidFill>
+          </a:ln>
+        </p:spPr>
+        <p:style>
+          <a:lnRef idx="1">
+            <a:schemeClr val="accent1"/>
+          </a:lnRef>
+          <a:fillRef idx="3">
+            <a:schemeClr val="accent1"/>
+          </a:fillRef>
+          <a:effectRef idx="2">
+            <a:schemeClr val="accent1"/>
+          </a:effectRef>
+          <a:fontRef idx="minor">
+            <a:schemeClr val="lt1"/>
+          </a:fontRef>
+        </p:style>
+        <p:txBody>
+          <a:bodyPr rtlCol="0" anchor="ctr"/>
+          <a:lstStyle/>
+          <a:p>
+            <a:pPr algn="ctr"/>
+          </a:p>
+        </p:txBody>
+      </p:sp>
+      <p:sp>
+        <p:nvSpPr>
+          <p:cNvPr id="51" name="Oval 50"/>
+          <p:cNvSpPr/>
+          <p:nvPr/>
+        </p:nvSpPr>
+        <p:spPr>
+          <a:xfrm>
+            <a:off x="22439376" y="9582912"/>
+            <a:ext cx="2779776" cy="2779776"/>
+          </a:xfrm>
+          <a:prstGeom prst="ellipse">
+            <a:avLst/>
+          </a:prstGeom>
+          <a:solidFill>
+            <a:srgbClr val="FFFFFF"/>
+          </a:solidFill>
+          <a:ln w="50800">
+            <a:solidFill>
+              <a:srgbClr val="1565C0"/>
+            </a:solidFill>
+          </a:ln>
+        </p:spPr>
+        <p:style>
+          <a:lnRef idx="1">
+            <a:schemeClr val="accent1"/>
+          </a:lnRef>
+          <a:fillRef idx="3">
+            <a:schemeClr val="accent1"/>
+          </a:fillRef>
+          <a:effectRef idx="2">
+            <a:schemeClr val="accent1"/>
+          </a:effectRef>
+          <a:fontRef idx="minor">
+            <a:schemeClr val="lt1"/>
+          </a:fontRef>
+        </p:style>
+        <p:txBody>
+          <a:bodyPr rtlCol="0" anchor="ctr"/>
+          <a:lstStyle/>
+          <a:p>
+            <a:pPr algn="ctr"/>
+          </a:p>
+        </p:txBody>
+      </p:sp>
+      <p:sp>
+        <p:nvSpPr>
+          <p:cNvPr id="52" name="Oval 51"/>
+          <p:cNvSpPr/>
+          <p:nvPr/>
+        </p:nvSpPr>
+        <p:spPr>
+          <a:xfrm>
+            <a:off x="22549104" y="9692640"/>
+            <a:ext cx="2560320" cy="2560320"/>
+          </a:xfrm>
+          <a:prstGeom prst="ellipse">
+            <a:avLst/>
+          </a:prstGeom>
+          <a:solidFill>
+            <a:srgbClr val="1565C0"/>
+          </a:solidFill>
+          <a:ln>
+            <a:noFill/>
+          </a:ln>
+        </p:spPr>
+        <p:style>
+          <a:lnRef idx="1">
+            <a:schemeClr val="accent1"/>
+          </a:lnRef>
+          <a:fillRef idx="3">
+            <a:schemeClr val="accent1"/>
+          </a:fillRef>
+          <a:effectRef idx="2">
+            <a:schemeClr val="accent1"/>
+          </a:effectRef>
+          <a:fontRef idx="minor">
+            <a:schemeClr val="lt1"/>
+          </a:fontRef>
+        </p:style>
+        <p:txBody>
+          <a:bodyPr rtlCol="0" anchor="ctr"/>
+          <a:lstStyle/>
+          <a:p>
+            <a:pPr algn="ctr"/>
+          </a:p>
+        </p:txBody>
+      </p:sp>
+      <p:sp>
+        <p:nvSpPr>
+          <p:cNvPr id="53" name="TextBox 52"/>
+          <p:cNvSpPr txBox="1"/>
+          <p:nvPr/>
+        </p:nvSpPr>
+        <p:spPr>
+          <a:xfrm>
+            <a:off x="23280624" y="10332720"/>
+            <a:ext cx="1097280" cy="1097280"/>
+          </a:xfrm>
+          <a:prstGeom prst="rect">
+            <a:avLst/>
+          </a:prstGeom>
+          <a:noFill/>
+        </p:spPr>
+        <p:txBody>
+          <a:bodyPr wrap="square">
+            <a:spAutoFit/>
+          </a:bodyPr>
+          <a:lstStyle/>
+          <a:p>
+            <a:pPr algn="ctr"/>
+            <a:r>
+              <a:rPr sz="6800" b="1" i="0">
+                <a:solidFill>
+                  <a:srgbClr val="FFFFFF"/>
+                </a:solidFill>
+                <a:latin typeface="Calibri"/>
+              </a:rPr>
+              <a:t>MA</a:t>
+            </a:r>
+          </a:p>
+        </p:txBody>
+      </p:sp>
+      <p:sp>
+        <p:nvSpPr>
+          <p:cNvPr id="54" name="TextBox 53"/>
+          <p:cNvSpPr txBox="1"/>
+          <p:nvPr/>
+        </p:nvSpPr>
+        <p:spPr>
+          <a:xfrm>
+            <a:off x="17885664" y="12344400"/>
+            <a:ext cx="11887200" cy="384048"/>
+          </a:xfrm>
+          <a:prstGeom prst="rect">
+            <a:avLst/>
+          </a:prstGeom>
+          <a:noFill/>
+        </p:spPr>
+        <p:txBody>
+          <a:bodyPr wrap="square">
+            <a:spAutoFit/>
+          </a:bodyPr>
+          <a:lstStyle/>
+          <a:p>
+            <a:pPr algn="ctr"/>
+            <a:r>
+              <a:rPr sz="2200" b="0" i="1">
+                <a:solidFill>
+                  <a:srgbClr val="757575"/>
+                </a:solidFill>
+                <a:latin typeface="Calibri"/>
+              </a:rPr>
+              <a:t>[ Replace with photo ]</a:t>
+            </a:r>
+          </a:p>
+        </p:txBody>
+      </p:sp>
+      <p:sp>
+        <p:nvSpPr>
+          <p:cNvPr id="55" name="TextBox 54"/>
+          <p:cNvSpPr txBox="1"/>
+          <p:nvPr/>
+        </p:nvSpPr>
+        <p:spPr>
+          <a:xfrm>
+            <a:off x="17885664" y="12765024"/>
+            <a:ext cx="11887200" cy="731520"/>
+          </a:xfrm>
+          <a:prstGeom prst="rect">
+            <a:avLst/>
+          </a:prstGeom>
+          <a:noFill/>
+        </p:spPr>
+        <p:txBody>
+          <a:bodyPr wrap="square">
+            <a:spAutoFit/>
+          </a:bodyPr>
+          <a:lstStyle/>
+          <a:p>
+            <a:pPr algn="ctr"/>
+            <a:r>
+              <a:rPr sz="4600" b="1" i="0">
+                <a:solidFill>
+                  <a:srgbClr val="0D47A1"/>
+                </a:solidFill>
+                <a:latin typeface="Calibri"/>
+              </a:rPr>
+              <a:t>Momina Ali</a:t>
+            </a:r>
+          </a:p>
+        </p:txBody>
+      </p:sp>
+      <p:sp>
+        <p:nvSpPr>
+          <p:cNvPr id="56" name="TextBox 55"/>
+          <p:cNvSpPr txBox="1"/>
+          <p:nvPr/>
+        </p:nvSpPr>
+        <p:spPr>
+          <a:xfrm>
+            <a:off x="17885664" y="13514832"/>
+            <a:ext cx="11887200" cy="502920"/>
+          </a:xfrm>
+          <a:prstGeom prst="rect">
+            <a:avLst/>
+          </a:prstGeom>
+          <a:noFill/>
+        </p:spPr>
+        <p:txBody>
+          <a:bodyPr wrap="square">
+            <a:spAutoFit/>
+          </a:bodyPr>
+          <a:lstStyle/>
+          <a:p>
+            <a:pPr algn="ctr"/>
+            <a:r>
+              <a:rPr sz="2800" b="0" i="1">
+                <a:solidFill>
+                  <a:srgbClr val="1565C0"/>
+                </a:solidFill>
+                <a:latin typeface="Calibri"/>
+              </a:rPr>
+              <a:t>Developer  ·  BS Robotics &amp; AI</a:t>
+            </a:r>
+          </a:p>
+        </p:txBody>
+      </p:sp>
+      <p:sp>
+        <p:nvSpPr>
+          <p:cNvPr id="57" name="Rectangle 56"/>
+          <p:cNvSpPr/>
+          <p:nvPr/>
+        </p:nvSpPr>
+        <p:spPr>
+          <a:xfrm>
+            <a:off x="22457664" y="13423392"/>
+            <a:ext cx="2743200" cy="45720"/>
+          </a:xfrm>
+          <a:prstGeom prst="rect">
+            <a:avLst/>
+          </a:prstGeom>
+          <a:solidFill>
+            <a:srgbClr val="42A5F5"/>
+          </a:solidFill>
+          <a:ln>
+            <a:noFill/>
+          </a:ln>
+        </p:spPr>
+        <p:style>
+          <a:lnRef idx="1">
+            <a:schemeClr val="accent1"/>
+          </a:lnRef>
+          <a:fillRef idx="3">
+            <a:schemeClr val="accent1"/>
+          </a:fillRef>
+          <a:effectRef idx="2">
+            <a:schemeClr val="accent1"/>
+          </a:effectRef>
+          <a:fontRef idx="minor">
+            <a:schemeClr val="lt1"/>
+          </a:fontRef>
+        </p:style>
+        <p:txBody>
+          <a:bodyPr rtlCol="0" anchor="ctr"/>
+          <a:lstStyle/>
+          <a:p>
+            <a:pPr algn="ctr"/>
+          </a:p>
+        </p:txBody>
+      </p:sp>
+      <p:sp>
+        <p:nvSpPr>
+          <p:cNvPr id="58" name="Rectangle 57"/>
+          <p:cNvSpPr/>
+          <p:nvPr/>
+        </p:nvSpPr>
+        <p:spPr>
+          <a:xfrm>
+            <a:off x="585216" y="13981176"/>
+            <a:ext cx="14442948" cy="6858000"/>
+          </a:xfrm>
+          <a:prstGeom prst="rect">
+            <a:avLst/>
+          </a:prstGeom>
+          <a:solidFill>
+            <a:srgbClr val="CCCCCC"/>
+          </a:solidFill>
+          <a:ln>
+            <a:noFill/>
+          </a:ln>
+        </p:spPr>
+        <p:style>
+          <a:lnRef idx="1">
+            <a:schemeClr val="accent1"/>
+          </a:lnRef>
+          <a:fillRef idx="3">
+            <a:schemeClr val="accent1"/>
+          </a:fillRef>
+          <a:effectRef idx="2">
+            <a:schemeClr val="accent1"/>
+          </a:effectRef>
+          <a:fontRef idx="minor">
+            <a:schemeClr val="lt1"/>
+          </a:fontRef>
+        </p:style>
+        <p:txBody>
+          <a:bodyPr rtlCol="0" anchor="ctr"/>
+          <a:lstStyle/>
+          <a:p>
+            <a:pPr algn="ctr"/>
+          </a:p>
+        </p:txBody>
+      </p:sp>
+      <p:sp>
+        <p:nvSpPr>
+          <p:cNvPr id="59" name="Rectangle 58"/>
+          <p:cNvSpPr/>
+          <p:nvPr/>
+        </p:nvSpPr>
+        <p:spPr>
+          <a:xfrm>
+            <a:off x="502920" y="13898880"/>
+            <a:ext cx="14442948" cy="6858000"/>
+          </a:xfrm>
+          <a:prstGeom prst="rect">
+            <a:avLst/>
+          </a:prstGeom>
+          <a:solidFill>
+            <a:srgbClr val="FFFFFF"/>
+          </a:solidFill>
+          <a:ln w="31750">
+            <a:solidFill>
+              <a:srgbClr val="1565C0"/>
+            </a:solidFill>
+          </a:ln>
+        </p:spPr>
+        <p:style>
+          <a:lnRef idx="1">
+            <a:schemeClr val="accent1"/>
+          </a:lnRef>
+          <a:fillRef idx="3">
+            <a:schemeClr val="accent1"/>
+          </a:fillRef>
+          <a:effectRef idx="2">
+            <a:schemeClr val="accent1"/>
+          </a:effectRef>
+          <a:fontRef idx="minor">
+            <a:schemeClr val="lt1"/>
+          </a:fontRef>
+        </p:style>
+        <p:txBody>
+          <a:bodyPr rtlCol="0" anchor="ctr"/>
+          <a:lstStyle/>
+          <a:p>
+            <a:pPr algn="ctr"/>
+          </a:p>
+        </p:txBody>
+      </p:sp>
+      <p:sp>
+        <p:nvSpPr>
+          <p:cNvPr id="60" name="Rectangle 59"/>
+          <p:cNvSpPr/>
+          <p:nvPr/>
+        </p:nvSpPr>
+        <p:spPr>
+          <a:xfrm>
+            <a:off x="502920" y="13898880"/>
+            <a:ext cx="14442948" cy="777240"/>
+          </a:xfrm>
+          <a:prstGeom prst="rect">
+            <a:avLst/>
+          </a:prstGeom>
+          <a:solidFill>
+            <a:srgbClr val="1565C0"/>
+          </a:solidFill>
+          <a:ln>
+            <a:noFill/>
+          </a:ln>
+        </p:spPr>
+        <p:style>
+          <a:lnRef idx="1">
+            <a:schemeClr val="accent1"/>
+          </a:lnRef>
+          <a:fillRef idx="3">
+            <a:schemeClr val="accent1"/>
+          </a:fillRef>
+          <a:effectRef idx="2">
+            <a:schemeClr val="accent1"/>
+          </a:effectRef>
+          <a:fontRef idx="minor">
+            <a:schemeClr val="lt1"/>
+          </a:fontRef>
+        </p:style>
+        <p:txBody>
+          <a:bodyPr rtlCol="0" anchor="ctr"/>
+          <a:lstStyle/>
+          <a:p>
+            <a:pPr algn="ctr"/>
+          </a:p>
+        </p:txBody>
+      </p:sp>
+      <p:sp>
+        <p:nvSpPr>
+          <p:cNvPr id="61" name="Rectangle 60"/>
+          <p:cNvSpPr/>
+          <p:nvPr/>
+        </p:nvSpPr>
+        <p:spPr>
+          <a:xfrm>
+            <a:off x="502920" y="14676120"/>
+            <a:ext cx="91440" cy="6080760"/>
+          </a:xfrm>
+          <a:prstGeom prst="rect">
+            <a:avLst/>
+          </a:prstGeom>
+          <a:solidFill>
+            <a:srgbClr val="42A5F5"/>
+          </a:solidFill>
+          <a:ln>
+            <a:noFill/>
+          </a:ln>
+        </p:spPr>
+        <p:style>
+          <a:lnRef idx="1">
+            <a:schemeClr val="accent1"/>
+          </a:lnRef>
+          <a:fillRef idx="3">
+            <a:schemeClr val="accent1"/>
+          </a:fillRef>
+          <a:effectRef idx="2">
+            <a:schemeClr val="accent1"/>
+          </a:effectRef>
+          <a:fontRef idx="minor">
+            <a:schemeClr val="lt1"/>
+          </a:fontRef>
+        </p:style>
+        <p:txBody>
+          <a:bodyPr rtlCol="0" anchor="ctr"/>
+          <a:lstStyle/>
+          <a:p>
+            <a:pPr algn="ctr"/>
+          </a:p>
+        </p:txBody>
+      </p:sp>
+      <p:sp>
+        <p:nvSpPr>
+          <p:cNvPr id="62" name="TextBox 61"/>
+          <p:cNvSpPr txBox="1"/>
+          <p:nvPr/>
+        </p:nvSpPr>
+        <p:spPr>
+          <a:xfrm>
+            <a:off x="704088" y="13972032"/>
+            <a:ext cx="14122908" cy="722376"/>
+          </a:xfrm>
+          <a:prstGeom prst="rect">
+            <a:avLst/>
+          </a:prstGeom>
+          <a:noFill/>
+        </p:spPr>
+        <p:txBody>
+          <a:bodyPr wrap="square">
+            <a:spAutoFit/>
+          </a:bodyPr>
+          <a:lstStyle/>
+          <a:p>
+            <a:pPr algn="l"/>
+            <a:r>
+              <a:rPr sz="4000" b="1" i="0">
+                <a:solidFill>
+                  <a:srgbClr val="FFFFFF"/>
+                </a:solidFill>
+                <a:latin typeface="Calibri"/>
+              </a:rPr>
               <a:t>About the Project</a:t>
             </a:r>
           </a:p>
@@ -4566,14 +5497,14 @@
       </p:sp>
       <p:sp>
         <p:nvSpPr>
-          <p:cNvPr id="40" name="TextBox 39"/>
+          <p:cNvPr id="63" name="TextBox 62"/>
           <p:cNvSpPr txBox="1"/>
           <p:nvPr/>
         </p:nvSpPr>
         <p:spPr>
           <a:xfrm>
-            <a:off x="758952" y="9573768"/>
-            <a:ext cx="13958316" cy="6153912"/>
+            <a:off x="758952" y="14785848"/>
+            <a:ext cx="13958316" cy="5879592"/>
           </a:xfrm>
           <a:prstGeom prst="rect">
             <a:avLst/>
@@ -4604,14 +5535,14 @@
       </p:sp>
       <p:sp>
         <p:nvSpPr>
-          <p:cNvPr id="41" name="Rectangle 40"/>
+          <p:cNvPr id="64" name="Rectangle 63"/>
           <p:cNvSpPr/>
           <p:nvPr/>
         </p:nvSpPr>
         <p:spPr>
           <a:xfrm>
-            <a:off x="585216" y="16285464"/>
-            <a:ext cx="14442948" cy="5669280"/>
+            <a:off x="585216" y="21223224"/>
+            <a:ext cx="14442948" cy="5303520"/>
           </a:xfrm>
           <a:prstGeom prst="rect">
             <a:avLst/>
@@ -4647,14 +5578,14 @@
       </p:sp>
       <p:sp>
         <p:nvSpPr>
-          <p:cNvPr id="42" name="Rectangle 41"/>
+          <p:cNvPr id="65" name="Rectangle 64"/>
           <p:cNvSpPr/>
           <p:nvPr/>
         </p:nvSpPr>
         <p:spPr>
           <a:xfrm>
-            <a:off x="502920" y="16203168"/>
-            <a:ext cx="14442948" cy="5669280"/>
+            <a:off x="502920" y="21140928"/>
+            <a:ext cx="14442948" cy="5303520"/>
           </a:xfrm>
           <a:prstGeom prst="rect">
             <a:avLst/>
@@ -4692,13 +5623,13 @@
       </p:sp>
       <p:sp>
         <p:nvSpPr>
-          <p:cNvPr id="43" name="Rectangle 42"/>
+          <p:cNvPr id="66" name="Rectangle 65"/>
           <p:cNvSpPr/>
           <p:nvPr/>
         </p:nvSpPr>
         <p:spPr>
           <a:xfrm>
-            <a:off x="502920" y="16203168"/>
+            <a:off x="502920" y="21140928"/>
             <a:ext cx="14442948" cy="777240"/>
           </a:xfrm>
           <a:prstGeom prst="rect">
@@ -4735,14 +5666,14 @@
       </p:sp>
       <p:sp>
         <p:nvSpPr>
-          <p:cNvPr id="44" name="Rectangle 43"/>
+          <p:cNvPr id="67" name="Rectangle 66"/>
           <p:cNvSpPr/>
           <p:nvPr/>
         </p:nvSpPr>
         <p:spPr>
           <a:xfrm>
-            <a:off x="502920" y="16980408"/>
-            <a:ext cx="91440" cy="4892040"/>
+            <a:off x="502920" y="21918168"/>
+            <a:ext cx="91440" cy="4526280"/>
           </a:xfrm>
           <a:prstGeom prst="rect">
             <a:avLst/>
@@ -4778,13 +5709,13 @@
       </p:sp>
       <p:sp>
         <p:nvSpPr>
-          <p:cNvPr id="45" name="TextBox 44"/>
+          <p:cNvPr id="68" name="TextBox 67"/>
           <p:cNvSpPr txBox="1"/>
           <p:nvPr/>
         </p:nvSpPr>
         <p:spPr>
           <a:xfrm>
-            <a:off x="704088" y="16276320"/>
+            <a:off x="704088" y="21214080"/>
             <a:ext cx="14122908" cy="722376"/>
           </a:xfrm>
           <a:prstGeom prst="rect">
@@ -4813,14 +5744,14 @@
       </p:sp>
       <p:sp>
         <p:nvSpPr>
-          <p:cNvPr id="46" name="Rectangle 45"/>
+          <p:cNvPr id="69" name="Rectangle 68"/>
           <p:cNvSpPr/>
           <p:nvPr/>
         </p:nvSpPr>
         <p:spPr>
           <a:xfrm>
-            <a:off x="758952" y="17090136"/>
-            <a:ext cx="6883146" cy="1280160"/>
+            <a:off x="758952" y="22027896"/>
+            <a:ext cx="6883146" cy="1207008"/>
           </a:xfrm>
           <a:prstGeom prst="rect">
             <a:avLst/>
@@ -4858,14 +5789,14 @@
       </p:sp>
       <p:sp>
         <p:nvSpPr>
-          <p:cNvPr id="47" name="TextBox 46"/>
+          <p:cNvPr id="70" name="TextBox 69"/>
           <p:cNvSpPr txBox="1"/>
           <p:nvPr/>
         </p:nvSpPr>
         <p:spPr>
           <a:xfrm>
-            <a:off x="868680" y="17181576"/>
-            <a:ext cx="6700266" cy="457200"/>
+            <a:off x="868680" y="22119336"/>
+            <a:ext cx="6700266" cy="475488"/>
           </a:xfrm>
           <a:prstGeom prst="rect">
             <a:avLst/>
@@ -4893,14 +5824,14 @@
       </p:sp>
       <p:sp>
         <p:nvSpPr>
-          <p:cNvPr id="48" name="TextBox 47"/>
+          <p:cNvPr id="71" name="TextBox 70"/>
           <p:cNvSpPr txBox="1"/>
           <p:nvPr/>
         </p:nvSpPr>
         <p:spPr>
           <a:xfrm>
-            <a:off x="868680" y="17620488"/>
-            <a:ext cx="6700266" cy="548640"/>
+            <a:off x="868680" y="22576536"/>
+            <a:ext cx="6700266" cy="502920"/>
           </a:xfrm>
           <a:prstGeom prst="rect">
             <a:avLst/>
@@ -4928,14 +5859,14 @@
       </p:sp>
       <p:sp>
         <p:nvSpPr>
-          <p:cNvPr id="49" name="Rectangle 48"/>
+          <p:cNvPr id="72" name="Rectangle 71"/>
           <p:cNvSpPr/>
           <p:nvPr/>
         </p:nvSpPr>
         <p:spPr>
           <a:xfrm>
-            <a:off x="758952" y="18507456"/>
-            <a:ext cx="6883146" cy="1280160"/>
+            <a:off x="7834122" y="22027896"/>
+            <a:ext cx="6883146" cy="1207008"/>
           </a:xfrm>
           <a:prstGeom prst="rect">
             <a:avLst/>
@@ -4973,14 +5904,14 @@
       </p:sp>
       <p:sp>
         <p:nvSpPr>
-          <p:cNvPr id="50" name="TextBox 49"/>
+          <p:cNvPr id="73" name="TextBox 72"/>
           <p:cNvSpPr txBox="1"/>
           <p:nvPr/>
         </p:nvSpPr>
         <p:spPr>
           <a:xfrm>
-            <a:off x="868680" y="18598896"/>
-            <a:ext cx="6700266" cy="457200"/>
+            <a:off x="7943850" y="22119336"/>
+            <a:ext cx="6700266" cy="475488"/>
           </a:xfrm>
           <a:prstGeom prst="rect">
             <a:avLst/>
@@ -5008,14 +5939,14 @@
       </p:sp>
       <p:sp>
         <p:nvSpPr>
-          <p:cNvPr id="51" name="TextBox 50"/>
+          <p:cNvPr id="74" name="TextBox 73"/>
           <p:cNvSpPr txBox="1"/>
           <p:nvPr/>
         </p:nvSpPr>
         <p:spPr>
           <a:xfrm>
-            <a:off x="868680" y="19037808"/>
-            <a:ext cx="6700266" cy="548640"/>
+            <a:off x="7943850" y="22576536"/>
+            <a:ext cx="6700266" cy="502920"/>
           </a:xfrm>
           <a:prstGeom prst="rect">
             <a:avLst/>
@@ -5043,20 +5974,20 @@
       </p:sp>
       <p:sp>
         <p:nvSpPr>
-          <p:cNvPr id="52" name="Rectangle 51"/>
+          <p:cNvPr id="75" name="Rectangle 74"/>
           <p:cNvSpPr/>
           <p:nvPr/>
         </p:nvSpPr>
         <p:spPr>
           <a:xfrm>
-            <a:off x="758952" y="19924776"/>
-            <a:ext cx="6883146" cy="1280160"/>
-          </a:xfrm>
-          <a:prstGeom prst="rect">
-            <a:avLst/>
-          </a:prstGeom>
-          <a:solidFill>
-            <a:srgbClr val="E3F2FD"/>
+            <a:off x="758952" y="23326344"/>
+            <a:ext cx="6883146" cy="1207008"/>
+          </a:xfrm>
+          <a:prstGeom prst="rect">
+            <a:avLst/>
+          </a:prstGeom>
+          <a:solidFill>
+            <a:srgbClr val="F0F7FF"/>
           </a:solidFill>
           <a:ln w="12700">
             <a:solidFill>
@@ -5088,14 +6019,14 @@
       </p:sp>
       <p:sp>
         <p:nvSpPr>
-          <p:cNvPr id="53" name="TextBox 52"/>
+          <p:cNvPr id="76" name="TextBox 75"/>
           <p:cNvSpPr txBox="1"/>
           <p:nvPr/>
         </p:nvSpPr>
         <p:spPr>
           <a:xfrm>
-            <a:off x="868680" y="20016216"/>
-            <a:ext cx="6700266" cy="457200"/>
+            <a:off x="868680" y="23417784"/>
+            <a:ext cx="6700266" cy="475488"/>
           </a:xfrm>
           <a:prstGeom prst="rect">
             <a:avLst/>
@@ -5123,14 +6054,14 @@
       </p:sp>
       <p:sp>
         <p:nvSpPr>
-          <p:cNvPr id="54" name="TextBox 53"/>
+          <p:cNvPr id="77" name="TextBox 76"/>
           <p:cNvSpPr txBox="1"/>
           <p:nvPr/>
         </p:nvSpPr>
         <p:spPr>
           <a:xfrm>
-            <a:off x="868680" y="20455128"/>
-            <a:ext cx="6700266" cy="548640"/>
+            <a:off x="868680" y="23874984"/>
+            <a:ext cx="6700266" cy="502920"/>
           </a:xfrm>
           <a:prstGeom prst="rect">
             <a:avLst/>
@@ -5158,20 +6089,20 @@
       </p:sp>
       <p:sp>
         <p:nvSpPr>
-          <p:cNvPr id="55" name="Rectangle 54"/>
+          <p:cNvPr id="78" name="Rectangle 77"/>
           <p:cNvSpPr/>
           <p:nvPr/>
         </p:nvSpPr>
         <p:spPr>
           <a:xfrm>
-            <a:off x="7834122" y="17090136"/>
-            <a:ext cx="6883146" cy="1280160"/>
-          </a:xfrm>
-          <a:prstGeom prst="rect">
-            <a:avLst/>
-          </a:prstGeom>
-          <a:solidFill>
-            <a:srgbClr val="F0F7FF"/>
+            <a:off x="7834122" y="23326344"/>
+            <a:ext cx="6883146" cy="1207008"/>
+          </a:xfrm>
+          <a:prstGeom prst="rect">
+            <a:avLst/>
+          </a:prstGeom>
+          <a:solidFill>
+            <a:srgbClr val="E3F2FD"/>
           </a:solidFill>
           <a:ln w="12700">
             <a:solidFill>
@@ -5203,14 +6134,14 @@
       </p:sp>
       <p:sp>
         <p:nvSpPr>
-          <p:cNvPr id="56" name="TextBox 55"/>
+          <p:cNvPr id="79" name="TextBox 78"/>
           <p:cNvSpPr txBox="1"/>
           <p:nvPr/>
         </p:nvSpPr>
         <p:spPr>
           <a:xfrm>
-            <a:off x="7943850" y="17181576"/>
-            <a:ext cx="6700266" cy="457200"/>
+            <a:off x="7943850" y="23417784"/>
+            <a:ext cx="6700266" cy="475488"/>
           </a:xfrm>
           <a:prstGeom prst="rect">
             <a:avLst/>
@@ -5238,14 +6169,14 @@
       </p:sp>
       <p:sp>
         <p:nvSpPr>
-          <p:cNvPr id="57" name="TextBox 56"/>
+          <p:cNvPr id="80" name="TextBox 79"/>
           <p:cNvSpPr txBox="1"/>
           <p:nvPr/>
         </p:nvSpPr>
         <p:spPr>
           <a:xfrm>
-            <a:off x="7943850" y="17620488"/>
-            <a:ext cx="6700266" cy="548640"/>
+            <a:off x="7943850" y="23874984"/>
+            <a:ext cx="6700266" cy="502920"/>
           </a:xfrm>
           <a:prstGeom prst="rect">
             <a:avLst/>
@@ -5273,14 +6204,14 @@
       </p:sp>
       <p:sp>
         <p:nvSpPr>
-          <p:cNvPr id="58" name="Rectangle 57"/>
+          <p:cNvPr id="81" name="Rectangle 80"/>
           <p:cNvSpPr/>
           <p:nvPr/>
         </p:nvSpPr>
         <p:spPr>
           <a:xfrm>
-            <a:off x="7834122" y="18507456"/>
-            <a:ext cx="6883146" cy="1280160"/>
+            <a:off x="758952" y="24624792"/>
+            <a:ext cx="6883146" cy="1207008"/>
           </a:xfrm>
           <a:prstGeom prst="rect">
             <a:avLst/>
@@ -5318,14 +6249,14 @@
       </p:sp>
       <p:sp>
         <p:nvSpPr>
-          <p:cNvPr id="59" name="TextBox 58"/>
+          <p:cNvPr id="82" name="TextBox 81"/>
           <p:cNvSpPr txBox="1"/>
           <p:nvPr/>
         </p:nvSpPr>
         <p:spPr>
           <a:xfrm>
-            <a:off x="7943850" y="18598896"/>
-            <a:ext cx="6700266" cy="457200"/>
+            <a:off x="868680" y="24716232"/>
+            <a:ext cx="6700266" cy="475488"/>
           </a:xfrm>
           <a:prstGeom prst="rect">
             <a:avLst/>
@@ -5353,14 +6284,14 @@
       </p:sp>
       <p:sp>
         <p:nvSpPr>
-          <p:cNvPr id="60" name="TextBox 59"/>
+          <p:cNvPr id="83" name="TextBox 82"/>
           <p:cNvSpPr txBox="1"/>
           <p:nvPr/>
         </p:nvSpPr>
         <p:spPr>
           <a:xfrm>
-            <a:off x="7943850" y="19037808"/>
-            <a:ext cx="6700266" cy="548640"/>
+            <a:off x="868680" y="25173432"/>
+            <a:ext cx="6700266" cy="502920"/>
           </a:xfrm>
           <a:prstGeom prst="rect">
             <a:avLst/>
@@ -5388,14 +6319,14 @@
       </p:sp>
       <p:sp>
         <p:nvSpPr>
-          <p:cNvPr id="61" name="Rectangle 60"/>
+          <p:cNvPr id="84" name="Rectangle 83"/>
           <p:cNvSpPr/>
           <p:nvPr/>
         </p:nvSpPr>
         <p:spPr>
           <a:xfrm>
-            <a:off x="7834122" y="19924776"/>
-            <a:ext cx="6883146" cy="1280160"/>
+            <a:off x="7834122" y="24624792"/>
+            <a:ext cx="6883146" cy="1207008"/>
           </a:xfrm>
           <a:prstGeom prst="rect">
             <a:avLst/>
@@ -5433,14 +6364,14 @@
       </p:sp>
       <p:sp>
         <p:nvSpPr>
-          <p:cNvPr id="62" name="TextBox 61"/>
+          <p:cNvPr id="85" name="TextBox 84"/>
           <p:cNvSpPr txBox="1"/>
           <p:nvPr/>
         </p:nvSpPr>
         <p:spPr>
           <a:xfrm>
-            <a:off x="7943850" y="20016216"/>
-            <a:ext cx="6700266" cy="457200"/>
+            <a:off x="7943850" y="24716232"/>
+            <a:ext cx="6700266" cy="475488"/>
           </a:xfrm>
           <a:prstGeom prst="rect">
             <a:avLst/>
@@ -5468,14 +6399,14 @@
       </p:sp>
       <p:sp>
         <p:nvSpPr>
-          <p:cNvPr id="63" name="TextBox 62"/>
+          <p:cNvPr id="86" name="TextBox 85"/>
           <p:cNvSpPr txBox="1"/>
           <p:nvPr/>
         </p:nvSpPr>
         <p:spPr>
           <a:xfrm>
-            <a:off x="7943850" y="20455128"/>
-            <a:ext cx="6700266" cy="548640"/>
+            <a:off x="7943850" y="25173432"/>
+            <a:ext cx="6700266" cy="502920"/>
           </a:xfrm>
           <a:prstGeom prst="rect">
             <a:avLst/>
@@ -5496,21 +6427,21 @@
                 </a:solidFill>
                 <a:latin typeface="Calibri"/>
               </a:rPr>
-              <a:t>Windows / Linux / macOS</a:t>
-            </a:r>
-          </a:p>
-        </p:txBody>
-      </p:sp>
-      <p:sp>
-        <p:nvSpPr>
-          <p:cNvPr id="64" name="Rectangle 63"/>
+              <a:t>Win / Linux / macOS</a:t>
+            </a:r>
+          </a:p>
+        </p:txBody>
+      </p:sp>
+      <p:sp>
+        <p:nvSpPr>
+          <p:cNvPr id="87" name="Rectangle 86"/>
           <p:cNvSpPr/>
           <p:nvPr/>
         </p:nvSpPr>
         <p:spPr>
           <a:xfrm>
-            <a:off x="585216" y="22338792"/>
-            <a:ext cx="14442948" cy="18946368"/>
+            <a:off x="585216" y="26910792"/>
+            <a:ext cx="14442948" cy="14374368"/>
           </a:xfrm>
           <a:prstGeom prst="rect">
             <a:avLst/>
@@ -5546,14 +6477,14 @@
       </p:sp>
       <p:sp>
         <p:nvSpPr>
-          <p:cNvPr id="65" name="Rectangle 64"/>
+          <p:cNvPr id="88" name="Rectangle 87"/>
           <p:cNvSpPr/>
           <p:nvPr/>
         </p:nvSpPr>
         <p:spPr>
           <a:xfrm>
-            <a:off x="502920" y="22256496"/>
-            <a:ext cx="14442948" cy="18946368"/>
+            <a:off x="502920" y="26828496"/>
+            <a:ext cx="14442948" cy="14374368"/>
           </a:xfrm>
           <a:prstGeom prst="rect">
             <a:avLst/>
@@ -5591,13 +6522,13 @@
       </p:sp>
       <p:sp>
         <p:nvSpPr>
-          <p:cNvPr id="66" name="Rectangle 65"/>
+          <p:cNvPr id="89" name="Rectangle 88"/>
           <p:cNvSpPr/>
           <p:nvPr/>
         </p:nvSpPr>
         <p:spPr>
           <a:xfrm>
-            <a:off x="502920" y="22256496"/>
+            <a:off x="502920" y="26828496"/>
             <a:ext cx="14442948" cy="777240"/>
           </a:xfrm>
           <a:prstGeom prst="rect">
@@ -5634,14 +6565,14 @@
       </p:sp>
       <p:sp>
         <p:nvSpPr>
-          <p:cNvPr id="67" name="Rectangle 66"/>
+          <p:cNvPr id="90" name="Rectangle 89"/>
           <p:cNvSpPr/>
           <p:nvPr/>
         </p:nvSpPr>
         <p:spPr>
           <a:xfrm>
-            <a:off x="502920" y="23033736"/>
-            <a:ext cx="91440" cy="18169128"/>
+            <a:off x="502920" y="27605736"/>
+            <a:ext cx="91440" cy="13597128"/>
           </a:xfrm>
           <a:prstGeom prst="rect">
             <a:avLst/>
@@ -5677,13 +6608,13 @@
       </p:sp>
       <p:sp>
         <p:nvSpPr>
-          <p:cNvPr id="68" name="TextBox 67"/>
+          <p:cNvPr id="91" name="TextBox 90"/>
           <p:cNvSpPr txBox="1"/>
           <p:nvPr/>
         </p:nvSpPr>
         <p:spPr>
           <a:xfrm>
-            <a:off x="704088" y="22329648"/>
+            <a:off x="704088" y="26901648"/>
             <a:ext cx="14122908" cy="722376"/>
           </a:xfrm>
           <a:prstGeom prst="rect">
@@ -5712,14 +6643,14 @@
       </p:sp>
       <p:sp>
         <p:nvSpPr>
-          <p:cNvPr id="69" name="Rectangle 68"/>
+          <p:cNvPr id="92" name="Rectangle 91"/>
           <p:cNvSpPr/>
           <p:nvPr/>
         </p:nvSpPr>
         <p:spPr>
           <a:xfrm>
-            <a:off x="612648" y="23143464"/>
-            <a:ext cx="14223492" cy="1959864"/>
+            <a:off x="612648" y="27715464"/>
+            <a:ext cx="14223492" cy="1451864"/>
           </a:xfrm>
           <a:prstGeom prst="rect">
             <a:avLst/>
@@ -5755,13 +6686,13 @@
       </p:sp>
       <p:sp>
         <p:nvSpPr>
-          <p:cNvPr id="70" name="Rectangle 69"/>
+          <p:cNvPr id="93" name="Rectangle 92"/>
           <p:cNvSpPr/>
           <p:nvPr/>
         </p:nvSpPr>
         <p:spPr>
           <a:xfrm>
-            <a:off x="758952" y="23931372"/>
+            <a:off x="758952" y="28249372"/>
             <a:ext cx="237744" cy="237744"/>
           </a:xfrm>
           <a:prstGeom prst="rect">
@@ -5798,14 +6729,14 @@
       </p:sp>
       <p:sp>
         <p:nvSpPr>
-          <p:cNvPr id="71" name="TextBox 70"/>
+          <p:cNvPr id="94" name="TextBox 93"/>
           <p:cNvSpPr txBox="1"/>
           <p:nvPr/>
         </p:nvSpPr>
         <p:spPr>
           <a:xfrm>
-            <a:off x="1161288" y="23198328"/>
-            <a:ext cx="13583412" cy="798576"/>
+            <a:off x="1161288" y="27770328"/>
+            <a:ext cx="13583412" cy="595376"/>
           </a:xfrm>
           <a:prstGeom prst="rect">
             <a:avLst/>
@@ -5833,14 +6764,14 @@
       </p:sp>
       <p:sp>
         <p:nvSpPr>
-          <p:cNvPr id="72" name="TextBox 71"/>
+          <p:cNvPr id="95" name="TextBox 94"/>
           <p:cNvSpPr txBox="1"/>
           <p:nvPr/>
         </p:nvSpPr>
         <p:spPr>
           <a:xfrm>
-            <a:off x="1161288" y="23942040"/>
-            <a:ext cx="13583412" cy="1237792"/>
+            <a:off x="1161288" y="28310840"/>
+            <a:ext cx="13583412" cy="922832"/>
           </a:xfrm>
           <a:prstGeom prst="rect">
             <a:avLst/>
@@ -5861,20 +6792,20 @@
                 </a:solidFill>
                 <a:latin typeface="Calibri"/>
               </a:rPr>
-              <a:t>Accepts .txt, .pdf, .jpg, .jpeg, .png, .bmp — all other formats are rejected with a clear, descriptive error message and non-zero exit code.</a:t>
-            </a:r>
-          </a:p>
-        </p:txBody>
-      </p:sp>
-      <p:sp>
-        <p:nvSpPr>
-          <p:cNvPr id="73" name="Rectangle 72"/>
+              <a:t>Accepts .txt, .pdf, .jpg, .jpeg, .png, .bmp — all other formats rejected with a clear error message.</a:t>
+            </a:r>
+          </a:p>
+        </p:txBody>
+      </p:sp>
+      <p:sp>
+        <p:nvSpPr>
+          <p:cNvPr id="96" name="Rectangle 95"/>
           <p:cNvSpPr/>
           <p:nvPr/>
         </p:nvSpPr>
         <p:spPr>
           <a:xfrm>
-            <a:off x="649224" y="25112472"/>
+            <a:off x="649224" y="29176472"/>
             <a:ext cx="14150340" cy="18288"/>
           </a:xfrm>
           <a:prstGeom prst="rect">
@@ -5911,13 +6842,13 @@
       </p:sp>
       <p:sp>
         <p:nvSpPr>
-          <p:cNvPr id="74" name="Rectangle 73"/>
+          <p:cNvPr id="97" name="Rectangle 96"/>
           <p:cNvSpPr/>
           <p:nvPr/>
         </p:nvSpPr>
         <p:spPr>
           <a:xfrm>
-            <a:off x="758952" y="25927812"/>
+            <a:off x="758952" y="29737812"/>
             <a:ext cx="237744" cy="237744"/>
           </a:xfrm>
           <a:prstGeom prst="rect">
@@ -5954,14 +6885,14 @@
       </p:sp>
       <p:sp>
         <p:nvSpPr>
-          <p:cNvPr id="75" name="TextBox 74"/>
+          <p:cNvPr id="98" name="TextBox 97"/>
           <p:cNvSpPr txBox="1"/>
           <p:nvPr/>
         </p:nvSpPr>
         <p:spPr>
           <a:xfrm>
-            <a:off x="1161288" y="25194768"/>
-            <a:ext cx="13583412" cy="798576"/>
+            <a:off x="1161288" y="29258768"/>
+            <a:ext cx="13583412" cy="595376"/>
           </a:xfrm>
           <a:prstGeom prst="rect">
             <a:avLst/>
@@ -5989,14 +6920,14 @@
       </p:sp>
       <p:sp>
         <p:nvSpPr>
-          <p:cNvPr id="76" name="TextBox 75"/>
+          <p:cNvPr id="99" name="TextBox 98"/>
           <p:cNvSpPr txBox="1"/>
           <p:nvPr/>
         </p:nvSpPr>
         <p:spPr>
           <a:xfrm>
-            <a:off x="1161288" y="25938480"/>
-            <a:ext cx="13583412" cy="1237792"/>
+            <a:off x="1161288" y="29799280"/>
+            <a:ext cx="13583412" cy="922832"/>
           </a:xfrm>
           <a:prstGeom prst="rect">
             <a:avLst/>
@@ -6024,13 +6955,13 @@
       </p:sp>
       <p:sp>
         <p:nvSpPr>
-          <p:cNvPr id="77" name="Rectangle 76"/>
+          <p:cNvPr id="100" name="Rectangle 99"/>
           <p:cNvSpPr/>
           <p:nvPr/>
         </p:nvSpPr>
         <p:spPr>
           <a:xfrm>
-            <a:off x="649224" y="27108912"/>
+            <a:off x="649224" y="30664912"/>
             <a:ext cx="14150340" cy="18288"/>
           </a:xfrm>
           <a:prstGeom prst="rect">
@@ -6067,14 +6998,14 @@
       </p:sp>
       <p:sp>
         <p:nvSpPr>
-          <p:cNvPr id="78" name="Rectangle 77"/>
+          <p:cNvPr id="101" name="Rectangle 100"/>
           <p:cNvSpPr/>
           <p:nvPr/>
         </p:nvSpPr>
         <p:spPr>
           <a:xfrm>
-            <a:off x="612648" y="27136344"/>
-            <a:ext cx="14223492" cy="1959864"/>
+            <a:off x="612648" y="30692344"/>
+            <a:ext cx="14223492" cy="1451864"/>
           </a:xfrm>
           <a:prstGeom prst="rect">
             <a:avLst/>
@@ -6110,13 +7041,13 @@
       </p:sp>
       <p:sp>
         <p:nvSpPr>
-          <p:cNvPr id="79" name="Rectangle 78"/>
+          <p:cNvPr id="102" name="Rectangle 101"/>
           <p:cNvSpPr/>
           <p:nvPr/>
         </p:nvSpPr>
         <p:spPr>
           <a:xfrm>
-            <a:off x="758952" y="27924252"/>
+            <a:off x="758952" y="31226252"/>
             <a:ext cx="237744" cy="237744"/>
           </a:xfrm>
           <a:prstGeom prst="rect">
@@ -6153,14 +7084,14 @@
       </p:sp>
       <p:sp>
         <p:nvSpPr>
-          <p:cNvPr id="80" name="TextBox 79"/>
+          <p:cNvPr id="103" name="TextBox 102"/>
           <p:cNvSpPr txBox="1"/>
           <p:nvPr/>
         </p:nvSpPr>
         <p:spPr>
           <a:xfrm>
-            <a:off x="1161288" y="27191208"/>
-            <a:ext cx="13583412" cy="798576"/>
+            <a:off x="1161288" y="30747208"/>
+            <a:ext cx="13583412" cy="595376"/>
           </a:xfrm>
           <a:prstGeom prst="rect">
             <a:avLst/>
@@ -6188,14 +7119,14 @@
       </p:sp>
       <p:sp>
         <p:nvSpPr>
-          <p:cNvPr id="81" name="TextBox 80"/>
+          <p:cNvPr id="104" name="TextBox 103"/>
           <p:cNvSpPr txBox="1"/>
           <p:nvPr/>
         </p:nvSpPr>
         <p:spPr>
           <a:xfrm>
-            <a:off x="1161288" y="27934920"/>
-            <a:ext cx="13583412" cy="1237792"/>
+            <a:off x="1161288" y="31287720"/>
+            <a:ext cx="13583412" cy="922832"/>
           </a:xfrm>
           <a:prstGeom prst="rect">
             <a:avLst/>
@@ -6223,13 +7154,13 @@
       </p:sp>
       <p:sp>
         <p:nvSpPr>
-          <p:cNvPr id="82" name="Rectangle 81"/>
+          <p:cNvPr id="105" name="Rectangle 104"/>
           <p:cNvSpPr/>
           <p:nvPr/>
         </p:nvSpPr>
         <p:spPr>
           <a:xfrm>
-            <a:off x="649224" y="29105352"/>
+            <a:off x="649224" y="32153352"/>
             <a:ext cx="14150340" cy="18288"/>
           </a:xfrm>
           <a:prstGeom prst="rect">
@@ -6266,13 +7197,13 @@
       </p:sp>
       <p:sp>
         <p:nvSpPr>
-          <p:cNvPr id="83" name="Rectangle 82"/>
+          <p:cNvPr id="106" name="Rectangle 105"/>
           <p:cNvSpPr/>
           <p:nvPr/>
         </p:nvSpPr>
         <p:spPr>
           <a:xfrm>
-            <a:off x="758952" y="29920692"/>
+            <a:off x="758952" y="32714692"/>
             <a:ext cx="237744" cy="237744"/>
           </a:xfrm>
           <a:prstGeom prst="rect">
@@ -6309,14 +7240,14 @@
       </p:sp>
       <p:sp>
         <p:nvSpPr>
-          <p:cNvPr id="84" name="TextBox 83"/>
+          <p:cNvPr id="107" name="TextBox 106"/>
           <p:cNvSpPr txBox="1"/>
           <p:nvPr/>
         </p:nvSpPr>
         <p:spPr>
           <a:xfrm>
-            <a:off x="1161288" y="29187648"/>
-            <a:ext cx="13583412" cy="798576"/>
+            <a:off x="1161288" y="32235648"/>
+            <a:ext cx="13583412" cy="595376"/>
           </a:xfrm>
           <a:prstGeom prst="rect">
             <a:avLst/>
@@ -6344,14 +7275,14 @@
       </p:sp>
       <p:sp>
         <p:nvSpPr>
-          <p:cNvPr id="85" name="TextBox 84"/>
+          <p:cNvPr id="108" name="TextBox 107"/>
           <p:cNvSpPr txBox="1"/>
           <p:nvPr/>
         </p:nvSpPr>
         <p:spPr>
           <a:xfrm>
-            <a:off x="1161288" y="29931360"/>
-            <a:ext cx="13583412" cy="1237792"/>
+            <a:off x="1161288" y="32776160"/>
+            <a:ext cx="13583412" cy="922832"/>
           </a:xfrm>
           <a:prstGeom prst="rect">
             <a:avLst/>
@@ -6372,20 +7303,20 @@
                 </a:solidFill>
                 <a:latin typeface="Calibri"/>
               </a:rPr>
-              <a:t>Compressed file saved as &lt;name&gt;_compressed.&lt;ext&gt; alongside the source file in the same directory — no path juggling.</a:t>
-            </a:r>
-          </a:p>
-        </p:txBody>
-      </p:sp>
-      <p:sp>
-        <p:nvSpPr>
-          <p:cNvPr id="86" name="Rectangle 85"/>
+              <a:t>Compressed file saved as &lt;name&gt;_compressed.&lt;ext&gt; in the same directory as the source file.</a:t>
+            </a:r>
+          </a:p>
+        </p:txBody>
+      </p:sp>
+      <p:sp>
+        <p:nvSpPr>
+          <p:cNvPr id="109" name="Rectangle 108"/>
           <p:cNvSpPr/>
           <p:nvPr/>
         </p:nvSpPr>
         <p:spPr>
           <a:xfrm>
-            <a:off x="649224" y="31101792"/>
+            <a:off x="649224" y="33641792"/>
             <a:ext cx="14150340" cy="18288"/>
           </a:xfrm>
           <a:prstGeom prst="rect">
@@ -6422,14 +7353,14 @@
       </p:sp>
       <p:sp>
         <p:nvSpPr>
-          <p:cNvPr id="87" name="Rectangle 86"/>
+          <p:cNvPr id="110" name="Rectangle 109"/>
           <p:cNvSpPr/>
           <p:nvPr/>
         </p:nvSpPr>
         <p:spPr>
           <a:xfrm>
-            <a:off x="612648" y="31129224"/>
-            <a:ext cx="14223492" cy="1959864"/>
+            <a:off x="612648" y="33669224"/>
+            <a:ext cx="14223492" cy="1451864"/>
           </a:xfrm>
           <a:prstGeom prst="rect">
             <a:avLst/>
@@ -6465,13 +7396,13 @@
       </p:sp>
       <p:sp>
         <p:nvSpPr>
-          <p:cNvPr id="88" name="Rectangle 87"/>
+          <p:cNvPr id="111" name="Rectangle 110"/>
           <p:cNvSpPr/>
           <p:nvPr/>
         </p:nvSpPr>
         <p:spPr>
           <a:xfrm>
-            <a:off x="758952" y="31917132"/>
+            <a:off x="758952" y="34203132"/>
             <a:ext cx="237744" cy="237744"/>
           </a:xfrm>
           <a:prstGeom prst="rect">
@@ -6508,14 +7439,14 @@
       </p:sp>
       <p:sp>
         <p:nvSpPr>
-          <p:cNvPr id="89" name="TextBox 88"/>
+          <p:cNvPr id="112" name="TextBox 111"/>
           <p:cNvSpPr txBox="1"/>
           <p:nvPr/>
         </p:nvSpPr>
         <p:spPr>
           <a:xfrm>
-            <a:off x="1161288" y="31184088"/>
-            <a:ext cx="13583412" cy="798576"/>
+            <a:off x="1161288" y="33724088"/>
+            <a:ext cx="13583412" cy="595376"/>
           </a:xfrm>
           <a:prstGeom prst="rect">
             <a:avLst/>
@@ -6543,14 +7474,14 @@
       </p:sp>
       <p:sp>
         <p:nvSpPr>
-          <p:cNvPr id="90" name="TextBox 89"/>
+          <p:cNvPr id="113" name="TextBox 112"/>
           <p:cNvSpPr txBox="1"/>
           <p:nvPr/>
         </p:nvSpPr>
         <p:spPr>
           <a:xfrm>
-            <a:off x="1161288" y="31927800"/>
-            <a:ext cx="13583412" cy="1237792"/>
+            <a:off x="1161288" y="34264600"/>
+            <a:ext cx="13583412" cy="922832"/>
           </a:xfrm>
           <a:prstGeom prst="rect">
             <a:avLst/>
@@ -6571,20 +7502,20 @@
                 </a:solidFill>
                 <a:latin typeface="Calibri"/>
               </a:rPr>
-              <a:t>If a compressed output already exists the tool prompts the user before overwriting, preventing accidental data loss.</a:t>
-            </a:r>
-          </a:p>
-        </p:txBody>
-      </p:sp>
-      <p:sp>
-        <p:nvSpPr>
-          <p:cNvPr id="91" name="Rectangle 90"/>
+              <a:t>Prompts the user before overwriting an existing output file to prevent accidental data loss.</a:t>
+            </a:r>
+          </a:p>
+        </p:txBody>
+      </p:sp>
+      <p:sp>
+        <p:nvSpPr>
+          <p:cNvPr id="114" name="Rectangle 113"/>
           <p:cNvSpPr/>
           <p:nvPr/>
         </p:nvSpPr>
         <p:spPr>
           <a:xfrm>
-            <a:off x="649224" y="33098232"/>
+            <a:off x="649224" y="35130232"/>
             <a:ext cx="14150340" cy="18288"/>
           </a:xfrm>
           <a:prstGeom prst="rect">
@@ -6621,13 +7552,13 @@
       </p:sp>
       <p:sp>
         <p:nvSpPr>
-          <p:cNvPr id="92" name="Rectangle 91"/>
+          <p:cNvPr id="115" name="Rectangle 114"/>
           <p:cNvSpPr/>
           <p:nvPr/>
         </p:nvSpPr>
         <p:spPr>
           <a:xfrm>
-            <a:off x="758952" y="33913572"/>
+            <a:off x="758952" y="35691572"/>
             <a:ext cx="237744" cy="237744"/>
           </a:xfrm>
           <a:prstGeom prst="rect">
@@ -6664,14 +7595,14 @@
       </p:sp>
       <p:sp>
         <p:nvSpPr>
-          <p:cNvPr id="93" name="TextBox 92"/>
+          <p:cNvPr id="116" name="TextBox 115"/>
           <p:cNvSpPr txBox="1"/>
           <p:nvPr/>
         </p:nvSpPr>
         <p:spPr>
           <a:xfrm>
-            <a:off x="1161288" y="33180528"/>
-            <a:ext cx="13583412" cy="798576"/>
+            <a:off x="1161288" y="35212528"/>
+            <a:ext cx="13583412" cy="595376"/>
           </a:xfrm>
           <a:prstGeom prst="rect">
             <a:avLst/>
@@ -6699,14 +7630,14 @@
       </p:sp>
       <p:sp>
         <p:nvSpPr>
-          <p:cNvPr id="94" name="TextBox 93"/>
+          <p:cNvPr id="117" name="TextBox 116"/>
           <p:cNvSpPr txBox="1"/>
           <p:nvPr/>
         </p:nvSpPr>
         <p:spPr>
           <a:xfrm>
-            <a:off x="1161288" y="33924240"/>
-            <a:ext cx="13583412" cy="1237792"/>
+            <a:off x="1161288" y="35753040"/>
+            <a:ext cx="13583412" cy="922832"/>
           </a:xfrm>
           <a:prstGeom prst="rect">
             <a:avLst/>
@@ -6727,20 +7658,20 @@
                 </a:solidFill>
                 <a:latin typeface="Calibri"/>
               </a:rPr>
-              <a:t>Corrupted or unreadable files surface a clear exception message and exit with a non-zero return code for scripting compatibility.</a:t>
-            </a:r>
-          </a:p>
-        </p:txBody>
-      </p:sp>
-      <p:sp>
-        <p:nvSpPr>
-          <p:cNvPr id="95" name="Rectangle 94"/>
+              <a:t>Corrupted or unreadable files surface a clear exception message and exit with a non-zero return code.</a:t>
+            </a:r>
+          </a:p>
+        </p:txBody>
+      </p:sp>
+      <p:sp>
+        <p:nvSpPr>
+          <p:cNvPr id="118" name="Rectangle 117"/>
           <p:cNvSpPr/>
           <p:nvPr/>
         </p:nvSpPr>
         <p:spPr>
           <a:xfrm>
-            <a:off x="649224" y="35094672"/>
+            <a:off x="649224" y="36618672"/>
             <a:ext cx="14150340" cy="18288"/>
           </a:xfrm>
           <a:prstGeom prst="rect">
@@ -6777,14 +7708,14 @@
       </p:sp>
       <p:sp>
         <p:nvSpPr>
-          <p:cNvPr id="96" name="Rectangle 95"/>
+          <p:cNvPr id="119" name="Rectangle 118"/>
           <p:cNvSpPr/>
           <p:nvPr/>
         </p:nvSpPr>
         <p:spPr>
           <a:xfrm>
-            <a:off x="612648" y="35122104"/>
-            <a:ext cx="14223492" cy="1959864"/>
+            <a:off x="612648" y="36646104"/>
+            <a:ext cx="14223492" cy="1451864"/>
           </a:xfrm>
           <a:prstGeom prst="rect">
             <a:avLst/>
@@ -6820,13 +7751,13 @@
       </p:sp>
       <p:sp>
         <p:nvSpPr>
-          <p:cNvPr id="97" name="Rectangle 96"/>
+          <p:cNvPr id="120" name="Rectangle 119"/>
           <p:cNvSpPr/>
           <p:nvPr/>
         </p:nvSpPr>
         <p:spPr>
           <a:xfrm>
-            <a:off x="758952" y="35910012"/>
+            <a:off x="758952" y="37180012"/>
             <a:ext cx="237744" cy="237744"/>
           </a:xfrm>
           <a:prstGeom prst="rect">
@@ -6863,14 +7794,14 @@
       </p:sp>
       <p:sp>
         <p:nvSpPr>
-          <p:cNvPr id="98" name="TextBox 97"/>
+          <p:cNvPr id="121" name="TextBox 120"/>
           <p:cNvSpPr txBox="1"/>
           <p:nvPr/>
         </p:nvSpPr>
         <p:spPr>
           <a:xfrm>
-            <a:off x="1161288" y="35176968"/>
-            <a:ext cx="13583412" cy="798576"/>
+            <a:off x="1161288" y="36700968"/>
+            <a:ext cx="13583412" cy="595376"/>
           </a:xfrm>
           <a:prstGeom prst="rect">
             <a:avLst/>
@@ -6898,14 +7829,14 @@
       </p:sp>
       <p:sp>
         <p:nvSpPr>
-          <p:cNvPr id="99" name="TextBox 98"/>
+          <p:cNvPr id="122" name="TextBox 121"/>
           <p:cNvSpPr txBox="1"/>
           <p:nvPr/>
         </p:nvSpPr>
         <p:spPr>
           <a:xfrm>
-            <a:off x="1161288" y="35920680"/>
-            <a:ext cx="13583412" cy="1237792"/>
+            <a:off x="1161288" y="37241480"/>
+            <a:ext cx="13583412" cy="922832"/>
           </a:xfrm>
           <a:prstGeom prst="rect">
             <a:avLst/>
@@ -6933,13 +7864,13 @@
       </p:sp>
       <p:sp>
         <p:nvSpPr>
-          <p:cNvPr id="100" name="Rectangle 99"/>
+          <p:cNvPr id="123" name="Rectangle 122"/>
           <p:cNvSpPr/>
           <p:nvPr/>
         </p:nvSpPr>
         <p:spPr>
           <a:xfrm>
-            <a:off x="649224" y="37091112"/>
+            <a:off x="649224" y="38107112"/>
             <a:ext cx="14150340" cy="18288"/>
           </a:xfrm>
           <a:prstGeom prst="rect">
@@ -6976,13 +7907,13 @@
       </p:sp>
       <p:sp>
         <p:nvSpPr>
-          <p:cNvPr id="101" name="Rectangle 100"/>
+          <p:cNvPr id="124" name="Rectangle 123"/>
           <p:cNvSpPr/>
           <p:nvPr/>
         </p:nvSpPr>
         <p:spPr>
           <a:xfrm>
-            <a:off x="758952" y="37906452"/>
+            <a:off x="758952" y="38668452"/>
             <a:ext cx="237744" cy="237744"/>
           </a:xfrm>
           <a:prstGeom prst="rect">
@@ -7019,14 +7950,14 @@
       </p:sp>
       <p:sp>
         <p:nvSpPr>
-          <p:cNvPr id="102" name="TextBox 101"/>
+          <p:cNvPr id="125" name="TextBox 124"/>
           <p:cNvSpPr txBox="1"/>
           <p:nvPr/>
         </p:nvSpPr>
         <p:spPr>
           <a:xfrm>
-            <a:off x="1161288" y="37173408"/>
-            <a:ext cx="13583412" cy="798576"/>
+            <a:off x="1161288" y="38189408"/>
+            <a:ext cx="13583412" cy="595376"/>
           </a:xfrm>
           <a:prstGeom prst="rect">
             <a:avLst/>
@@ -7054,14 +7985,14 @@
       </p:sp>
       <p:sp>
         <p:nvSpPr>
-          <p:cNvPr id="103" name="TextBox 102"/>
+          <p:cNvPr id="126" name="TextBox 125"/>
           <p:cNvSpPr txBox="1"/>
           <p:nvPr/>
         </p:nvSpPr>
         <p:spPr>
           <a:xfrm>
-            <a:off x="1161288" y="37917120"/>
-            <a:ext cx="13583412" cy="1237792"/>
+            <a:off x="1161288" y="38729920"/>
+            <a:ext cx="13583412" cy="922832"/>
           </a:xfrm>
           <a:prstGeom prst="rect">
             <a:avLst/>
@@ -7089,13 +8020,13 @@
       </p:sp>
       <p:sp>
         <p:nvSpPr>
-          <p:cNvPr id="104" name="Rectangle 103"/>
+          <p:cNvPr id="127" name="Rectangle 126"/>
           <p:cNvSpPr/>
           <p:nvPr/>
         </p:nvSpPr>
         <p:spPr>
           <a:xfrm>
-            <a:off x="649224" y="39087552"/>
+            <a:off x="649224" y="39595552"/>
             <a:ext cx="14150340" cy="18288"/>
           </a:xfrm>
           <a:prstGeom prst="rect">
@@ -7132,14 +8063,14 @@
       </p:sp>
       <p:sp>
         <p:nvSpPr>
-          <p:cNvPr id="105" name="Rectangle 104"/>
+          <p:cNvPr id="128" name="Rectangle 127"/>
           <p:cNvSpPr/>
           <p:nvPr/>
         </p:nvSpPr>
         <p:spPr>
           <a:xfrm>
-            <a:off x="612648" y="39114984"/>
-            <a:ext cx="14223492" cy="1959864"/>
+            <a:off x="612648" y="39622984"/>
+            <a:ext cx="14223492" cy="1451864"/>
           </a:xfrm>
           <a:prstGeom prst="rect">
             <a:avLst/>
@@ -7175,13 +8106,13 @@
       </p:sp>
       <p:sp>
         <p:nvSpPr>
-          <p:cNvPr id="106" name="Rectangle 105"/>
+          <p:cNvPr id="129" name="Rectangle 128"/>
           <p:cNvSpPr/>
           <p:nvPr/>
         </p:nvSpPr>
         <p:spPr>
           <a:xfrm>
-            <a:off x="758952" y="39902892"/>
+            <a:off x="758952" y="40156892"/>
             <a:ext cx="237744" cy="237744"/>
           </a:xfrm>
           <a:prstGeom prst="rect">
@@ -7218,14 +8149,14 @@
       </p:sp>
       <p:sp>
         <p:nvSpPr>
-          <p:cNvPr id="107" name="TextBox 106"/>
+          <p:cNvPr id="130" name="TextBox 129"/>
           <p:cNvSpPr txBox="1"/>
           <p:nvPr/>
         </p:nvSpPr>
         <p:spPr>
           <a:xfrm>
-            <a:off x="1161288" y="39169848"/>
-            <a:ext cx="13583412" cy="798576"/>
+            <a:off x="1161288" y="39677848"/>
+            <a:ext cx="13583412" cy="595376"/>
           </a:xfrm>
           <a:prstGeom prst="rect">
             <a:avLst/>
@@ -7253,14 +8184,14 @@
       </p:sp>
       <p:sp>
         <p:nvSpPr>
-          <p:cNvPr id="108" name="TextBox 107"/>
+          <p:cNvPr id="131" name="TextBox 130"/>
           <p:cNvSpPr txBox="1"/>
           <p:nvPr/>
         </p:nvSpPr>
         <p:spPr>
           <a:xfrm>
-            <a:off x="1161288" y="39913560"/>
-            <a:ext cx="13583412" cy="1237792"/>
+            <a:off x="1161288" y="40218360"/>
+            <a:ext cx="13583412" cy="922832"/>
           </a:xfrm>
           <a:prstGeom prst="rect">
             <a:avLst/>
@@ -7281,14 +8212,14 @@
                 </a:solidFill>
                 <a:latin typeface="Calibri"/>
               </a:rPr>
-              <a:t>Tested on Windows 10/11, Ubuntu 22.04 LTS and macOS 13 Ventura with Python 3.10+. Single-file deployment via PyInstaller.</a:t>
-            </a:r>
-          </a:p>
-        </p:txBody>
-      </p:sp>
-      <p:sp>
-        <p:nvSpPr>
-          <p:cNvPr id="109" name="Rectangle 108"/>
+              <a:t>Tested on Windows 10/11, Ubuntu 22.04 LTS and macOS 13 Ventura with Python 3.10+.</a:t>
+            </a:r>
+          </a:p>
+        </p:txBody>
+      </p:sp>
+      <p:sp>
+        <p:nvSpPr>
+          <p:cNvPr id="132" name="Rectangle 131"/>
           <p:cNvSpPr/>
           <p:nvPr/>
         </p:nvSpPr>
@@ -7331,14 +8262,14 @@
       </p:sp>
       <p:sp>
         <p:nvSpPr>
-          <p:cNvPr id="110" name="Rectangle 109"/>
+          <p:cNvPr id="133" name="Rectangle 132"/>
           <p:cNvSpPr/>
           <p:nvPr/>
         </p:nvSpPr>
         <p:spPr>
           <a:xfrm>
-            <a:off x="15412212" y="8769096"/>
-            <a:ext cx="14442948" cy="8778240"/>
+            <a:off x="15412212" y="13981176"/>
+            <a:ext cx="14442948" cy="8229600"/>
           </a:xfrm>
           <a:prstGeom prst="rect">
             <a:avLst/>
@@ -7374,14 +8305,14 @@
       </p:sp>
       <p:sp>
         <p:nvSpPr>
-          <p:cNvPr id="111" name="Rectangle 110"/>
+          <p:cNvPr id="134" name="Rectangle 133"/>
           <p:cNvSpPr/>
           <p:nvPr/>
         </p:nvSpPr>
         <p:spPr>
           <a:xfrm>
-            <a:off x="15329916" y="8686800"/>
-            <a:ext cx="14442948" cy="8778240"/>
+            <a:off x="15329916" y="13898880"/>
+            <a:ext cx="14442948" cy="8229600"/>
           </a:xfrm>
           <a:prstGeom prst="rect">
             <a:avLst/>
@@ -7419,13 +8350,13 @@
       </p:sp>
       <p:sp>
         <p:nvSpPr>
-          <p:cNvPr id="112" name="Rectangle 111"/>
+          <p:cNvPr id="135" name="Rectangle 134"/>
           <p:cNvSpPr/>
           <p:nvPr/>
         </p:nvSpPr>
         <p:spPr>
           <a:xfrm>
-            <a:off x="15329916" y="8686800"/>
+            <a:off x="15329916" y="13898880"/>
             <a:ext cx="14442948" cy="777240"/>
           </a:xfrm>
           <a:prstGeom prst="rect">
@@ -7462,14 +8393,14 @@
       </p:sp>
       <p:sp>
         <p:nvSpPr>
-          <p:cNvPr id="113" name="Rectangle 112"/>
+          <p:cNvPr id="136" name="Rectangle 135"/>
           <p:cNvSpPr/>
           <p:nvPr/>
         </p:nvSpPr>
         <p:spPr>
           <a:xfrm>
-            <a:off x="15329916" y="9464040"/>
-            <a:ext cx="91440" cy="8001000"/>
+            <a:off x="15329916" y="14676120"/>
+            <a:ext cx="91440" cy="7452360"/>
           </a:xfrm>
           <a:prstGeom prst="rect">
             <a:avLst/>
@@ -7505,13 +8436,13 @@
       </p:sp>
       <p:sp>
         <p:nvSpPr>
-          <p:cNvPr id="114" name="TextBox 113"/>
+          <p:cNvPr id="137" name="TextBox 136"/>
           <p:cNvSpPr txBox="1"/>
           <p:nvPr/>
         </p:nvSpPr>
         <p:spPr>
           <a:xfrm>
-            <a:off x="15531084" y="8759952"/>
+            <a:off x="15531084" y="13972032"/>
             <a:ext cx="14122908" cy="722376"/>
           </a:xfrm>
           <a:prstGeom prst="rect">
@@ -7540,14 +8471,14 @@
       </p:sp>
       <p:sp>
         <p:nvSpPr>
-          <p:cNvPr id="115" name="Rectangle 114"/>
+          <p:cNvPr id="138" name="Rectangle 137"/>
           <p:cNvSpPr/>
           <p:nvPr/>
         </p:nvSpPr>
         <p:spPr>
           <a:xfrm>
-            <a:off x="15439644" y="9573768"/>
-            <a:ext cx="14223492" cy="1523390"/>
+            <a:off x="15439644" y="14785848"/>
+            <a:ext cx="14223492" cy="1413662"/>
           </a:xfrm>
           <a:prstGeom prst="rect">
             <a:avLst/>
@@ -7583,13 +8514,13 @@
       </p:sp>
       <p:sp>
         <p:nvSpPr>
-          <p:cNvPr id="116" name="Rectangle 115"/>
+          <p:cNvPr id="139" name="Rectangle 138"/>
           <p:cNvSpPr/>
           <p:nvPr/>
         </p:nvSpPr>
         <p:spPr>
           <a:xfrm>
-            <a:off x="15585948" y="10088575"/>
+            <a:off x="15585948" y="15245791"/>
             <a:ext cx="347472" cy="347472"/>
           </a:xfrm>
           <a:prstGeom prst="rect">
@@ -7626,13 +8557,13 @@
       </p:sp>
       <p:sp>
         <p:nvSpPr>
-          <p:cNvPr id="117" name="TextBox 116"/>
+          <p:cNvPr id="140" name="TextBox 139"/>
           <p:cNvSpPr txBox="1"/>
           <p:nvPr/>
         </p:nvSpPr>
         <p:spPr>
           <a:xfrm>
-            <a:off x="15585948" y="10088575"/>
+            <a:off x="15585948" y="15245791"/>
             <a:ext cx="347472" cy="347472"/>
           </a:xfrm>
           <a:prstGeom prst="rect">
@@ -7661,14 +8592,14 @@
       </p:sp>
       <p:sp>
         <p:nvSpPr>
-          <p:cNvPr id="118" name="TextBox 117"/>
+          <p:cNvPr id="141" name="TextBox 140"/>
           <p:cNvSpPr txBox="1"/>
           <p:nvPr/>
         </p:nvSpPr>
         <p:spPr>
           <a:xfrm>
-            <a:off x="16116300" y="9628632"/>
-            <a:ext cx="13455396" cy="623986"/>
+            <a:off x="16116300" y="14840712"/>
+            <a:ext cx="13455396" cy="580095"/>
           </a:xfrm>
           <a:prstGeom prst="rect">
             <a:avLst/>
@@ -7696,14 +8627,14 @@
       </p:sp>
       <p:sp>
         <p:nvSpPr>
-          <p:cNvPr id="119" name="TextBox 118"/>
+          <p:cNvPr id="142" name="TextBox 141"/>
           <p:cNvSpPr txBox="1"/>
           <p:nvPr/>
         </p:nvSpPr>
         <p:spPr>
           <a:xfrm>
-            <a:off x="16116300" y="10197754"/>
-            <a:ext cx="13455396" cy="935979"/>
+            <a:off x="16116300" y="15365943"/>
+            <a:ext cx="13455396" cy="870143"/>
           </a:xfrm>
           <a:prstGeom prst="rect">
             <a:avLst/>
@@ -7724,20 +8655,20 @@
                 </a:solidFill>
                 <a:latin typeface="Calibri"/>
               </a:rPr>
-              <a:t>Compress document file sizes to optimise local storage usage and network bandwidth when sharing files across teams.</a:t>
-            </a:r>
-          </a:p>
-        </p:txBody>
-      </p:sp>
-      <p:sp>
-        <p:nvSpPr>
-          <p:cNvPr id="120" name="Rectangle 119"/>
+              <a:t>Compress document file sizes to optimise local storage usage and network bandwidth when sharing files.</a:t>
+            </a:r>
+          </a:p>
+        </p:txBody>
+      </p:sp>
+      <p:sp>
+        <p:nvSpPr>
+          <p:cNvPr id="143" name="Rectangle 142"/>
           <p:cNvSpPr/>
           <p:nvPr/>
         </p:nvSpPr>
         <p:spPr>
           <a:xfrm>
-            <a:off x="15476220" y="11106302"/>
+            <a:off x="15476220" y="16208654"/>
             <a:ext cx="14150340" cy="18288"/>
           </a:xfrm>
           <a:prstGeom prst="rect">
@@ -7774,13 +8705,13 @@
       </p:sp>
       <p:sp>
         <p:nvSpPr>
-          <p:cNvPr id="121" name="Rectangle 120"/>
+          <p:cNvPr id="144" name="Rectangle 143"/>
           <p:cNvSpPr/>
           <p:nvPr/>
         </p:nvSpPr>
         <p:spPr>
           <a:xfrm>
-            <a:off x="15585948" y="11648541"/>
+            <a:off x="15585948" y="16696029"/>
             <a:ext cx="347472" cy="347472"/>
           </a:xfrm>
           <a:prstGeom prst="rect">
@@ -7817,13 +8748,13 @@
       </p:sp>
       <p:sp>
         <p:nvSpPr>
-          <p:cNvPr id="122" name="TextBox 121"/>
+          <p:cNvPr id="145" name="TextBox 144"/>
           <p:cNvSpPr txBox="1"/>
           <p:nvPr/>
         </p:nvSpPr>
         <p:spPr>
           <a:xfrm>
-            <a:off x="15585948" y="11648541"/>
+            <a:off x="15585948" y="16696029"/>
             <a:ext cx="347472" cy="347472"/>
           </a:xfrm>
           <a:prstGeom prst="rect">
@@ -7852,14 +8783,14 @@
       </p:sp>
       <p:sp>
         <p:nvSpPr>
-          <p:cNvPr id="123" name="TextBox 122"/>
+          <p:cNvPr id="146" name="TextBox 145"/>
           <p:cNvSpPr txBox="1"/>
           <p:nvPr/>
         </p:nvSpPr>
         <p:spPr>
           <a:xfrm>
-            <a:off x="16116300" y="11188598"/>
-            <a:ext cx="13455396" cy="623986"/>
+            <a:off x="16116300" y="16290950"/>
+            <a:ext cx="13455396" cy="580095"/>
           </a:xfrm>
           <a:prstGeom prst="rect">
             <a:avLst/>
@@ -7887,14 +8818,14 @@
       </p:sp>
       <p:sp>
         <p:nvSpPr>
-          <p:cNvPr id="124" name="TextBox 123"/>
+          <p:cNvPr id="147" name="TextBox 146"/>
           <p:cNvSpPr txBox="1"/>
           <p:nvPr/>
         </p:nvSpPr>
         <p:spPr>
           <a:xfrm>
-            <a:off x="16116300" y="11757720"/>
-            <a:ext cx="13455396" cy="935979"/>
+            <a:off x="16116300" y="16816181"/>
+            <a:ext cx="13455396" cy="870143"/>
           </a:xfrm>
           <a:prstGeom prst="rect">
             <a:avLst/>
@@ -7922,13 +8853,13 @@
       </p:sp>
       <p:sp>
         <p:nvSpPr>
-          <p:cNvPr id="125" name="Rectangle 124"/>
+          <p:cNvPr id="148" name="Rectangle 147"/>
           <p:cNvSpPr/>
           <p:nvPr/>
         </p:nvSpPr>
         <p:spPr>
           <a:xfrm>
-            <a:off x="15476220" y="12666268"/>
+            <a:off x="15476220" y="17658892"/>
             <a:ext cx="14150340" cy="18288"/>
           </a:xfrm>
           <a:prstGeom prst="rect">
@@ -7965,14 +8896,14 @@
       </p:sp>
       <p:sp>
         <p:nvSpPr>
-          <p:cNvPr id="126" name="Rectangle 125"/>
+          <p:cNvPr id="149" name="Rectangle 148"/>
           <p:cNvSpPr/>
           <p:nvPr/>
         </p:nvSpPr>
         <p:spPr>
           <a:xfrm>
-            <a:off x="15439644" y="12693700"/>
-            <a:ext cx="14223492" cy="1523390"/>
+            <a:off x="15439644" y="17686324"/>
+            <a:ext cx="14223492" cy="1413662"/>
           </a:xfrm>
           <a:prstGeom prst="rect">
             <a:avLst/>
@@ -8008,13 +8939,13 @@
       </p:sp>
       <p:sp>
         <p:nvSpPr>
-          <p:cNvPr id="127" name="Rectangle 126"/>
+          <p:cNvPr id="150" name="Rectangle 149"/>
           <p:cNvSpPr/>
           <p:nvPr/>
         </p:nvSpPr>
         <p:spPr>
           <a:xfrm>
-            <a:off x="15585948" y="13208508"/>
+            <a:off x="15585948" y="18146268"/>
             <a:ext cx="347472" cy="347472"/>
           </a:xfrm>
           <a:prstGeom prst="rect">
@@ -8051,13 +8982,13 @@
       </p:sp>
       <p:sp>
         <p:nvSpPr>
-          <p:cNvPr id="128" name="TextBox 127"/>
+          <p:cNvPr id="151" name="TextBox 150"/>
           <p:cNvSpPr txBox="1"/>
           <p:nvPr/>
         </p:nvSpPr>
         <p:spPr>
           <a:xfrm>
-            <a:off x="15585948" y="13208508"/>
+            <a:off x="15585948" y="18146268"/>
             <a:ext cx="347472" cy="347472"/>
           </a:xfrm>
           <a:prstGeom prst="rect">
@@ -8086,14 +9017,14 @@
       </p:sp>
       <p:sp>
         <p:nvSpPr>
-          <p:cNvPr id="129" name="TextBox 128"/>
+          <p:cNvPr id="152" name="TextBox 151"/>
           <p:cNvSpPr txBox="1"/>
           <p:nvPr/>
         </p:nvSpPr>
         <p:spPr>
           <a:xfrm>
-            <a:off x="16116300" y="12748564"/>
-            <a:ext cx="13455396" cy="623986"/>
+            <a:off x="16116300" y="17741188"/>
+            <a:ext cx="13455396" cy="580095"/>
           </a:xfrm>
           <a:prstGeom prst="rect">
             <a:avLst/>
@@ -8121,14 +9052,14 @@
       </p:sp>
       <p:sp>
         <p:nvSpPr>
-          <p:cNvPr id="130" name="TextBox 129"/>
+          <p:cNvPr id="153" name="TextBox 152"/>
           <p:cNvSpPr txBox="1"/>
           <p:nvPr/>
         </p:nvSpPr>
         <p:spPr>
           <a:xfrm>
-            <a:off x="16116300" y="13317687"/>
-            <a:ext cx="13455396" cy="935979"/>
+            <a:off x="16116300" y="18266420"/>
+            <a:ext cx="13455396" cy="870143"/>
           </a:xfrm>
           <a:prstGeom prst="rect">
             <a:avLst/>
@@ -8149,20 +9080,20 @@
                 </a:solidFill>
                 <a:latin typeface="Calibri"/>
               </a:rPr>
-              <a:t>Offer a simple lossless mode for everyday use and an aggressive high-ratio mode for maximum space savings.</a:t>
-            </a:r>
-          </a:p>
-        </p:txBody>
-      </p:sp>
-      <p:sp>
-        <p:nvSpPr>
-          <p:cNvPr id="131" name="Rectangle 130"/>
+              <a:t>Offer a simple lossless mode for everyday use and an aggressive high-ratio mode for maximum savings.</a:t>
+            </a:r>
+          </a:p>
+        </p:txBody>
+      </p:sp>
+      <p:sp>
+        <p:nvSpPr>
+          <p:cNvPr id="154" name="Rectangle 153"/>
           <p:cNvSpPr/>
           <p:nvPr/>
         </p:nvSpPr>
         <p:spPr>
           <a:xfrm>
-            <a:off x="15476220" y="14226235"/>
+            <a:off x="15476220" y="19109131"/>
             <a:ext cx="14150340" cy="18288"/>
           </a:xfrm>
           <a:prstGeom prst="rect">
@@ -8199,13 +9130,13 @@
       </p:sp>
       <p:sp>
         <p:nvSpPr>
-          <p:cNvPr id="132" name="Rectangle 131"/>
+          <p:cNvPr id="155" name="Rectangle 154"/>
           <p:cNvSpPr/>
           <p:nvPr/>
         </p:nvSpPr>
         <p:spPr>
           <a:xfrm>
-            <a:off x="15585948" y="14768474"/>
+            <a:off x="15585948" y="19596506"/>
             <a:ext cx="347472" cy="347472"/>
           </a:xfrm>
           <a:prstGeom prst="rect">
@@ -8242,13 +9173,13 @@
       </p:sp>
       <p:sp>
         <p:nvSpPr>
-          <p:cNvPr id="133" name="TextBox 132"/>
+          <p:cNvPr id="156" name="TextBox 155"/>
           <p:cNvSpPr txBox="1"/>
           <p:nvPr/>
         </p:nvSpPr>
         <p:spPr>
           <a:xfrm>
-            <a:off x="15585948" y="14768474"/>
+            <a:off x="15585948" y="19596506"/>
             <a:ext cx="347472" cy="347472"/>
           </a:xfrm>
           <a:prstGeom prst="rect">
@@ -8277,14 +9208,14 @@
       </p:sp>
       <p:sp>
         <p:nvSpPr>
-          <p:cNvPr id="134" name="TextBox 133"/>
+          <p:cNvPr id="157" name="TextBox 156"/>
           <p:cNvSpPr txBox="1"/>
           <p:nvPr/>
         </p:nvSpPr>
         <p:spPr>
           <a:xfrm>
-            <a:off x="16116300" y="14308531"/>
-            <a:ext cx="13455396" cy="623986"/>
+            <a:off x="16116300" y="19191427"/>
+            <a:ext cx="13455396" cy="580095"/>
           </a:xfrm>
           <a:prstGeom prst="rect">
             <a:avLst/>
@@ -8312,14 +9243,14 @@
       </p:sp>
       <p:sp>
         <p:nvSpPr>
-          <p:cNvPr id="135" name="TextBox 134"/>
+          <p:cNvPr id="158" name="TextBox 157"/>
           <p:cNvSpPr txBox="1"/>
           <p:nvPr/>
         </p:nvSpPr>
         <p:spPr>
           <a:xfrm>
-            <a:off x="16116300" y="14877653"/>
-            <a:ext cx="13455396" cy="935979"/>
+            <a:off x="16116300" y="19716658"/>
+            <a:ext cx="13455396" cy="870143"/>
           </a:xfrm>
           <a:prstGeom prst="rect">
             <a:avLst/>
@@ -8340,20 +9271,20 @@
                 </a:solidFill>
                 <a:latin typeface="Calibri"/>
               </a:rPr>
-              <a:t>Provide clear prompts, live progress indicators and helpful error messages so non-expert users can operate the tool with confidence.</a:t>
-            </a:r>
-          </a:p>
-        </p:txBody>
-      </p:sp>
-      <p:sp>
-        <p:nvSpPr>
-          <p:cNvPr id="136" name="Rectangle 135"/>
+              <a:t>Provide clear prompts, live progress indicators and helpful error messages for non-expert users.</a:t>
+            </a:r>
+          </a:p>
+        </p:txBody>
+      </p:sp>
+      <p:sp>
+        <p:nvSpPr>
+          <p:cNvPr id="159" name="Rectangle 158"/>
           <p:cNvSpPr/>
           <p:nvPr/>
         </p:nvSpPr>
         <p:spPr>
           <a:xfrm>
-            <a:off x="15476220" y="15786201"/>
+            <a:off x="15476220" y="20559369"/>
             <a:ext cx="14150340" cy="18288"/>
           </a:xfrm>
           <a:prstGeom prst="rect">
@@ -8390,14 +9321,14 @@
       </p:sp>
       <p:sp>
         <p:nvSpPr>
-          <p:cNvPr id="137" name="Rectangle 136"/>
+          <p:cNvPr id="160" name="Rectangle 159"/>
           <p:cNvSpPr/>
           <p:nvPr/>
         </p:nvSpPr>
         <p:spPr>
           <a:xfrm>
-            <a:off x="15439644" y="15813633"/>
-            <a:ext cx="14223492" cy="1523390"/>
+            <a:off x="15439644" y="20586801"/>
+            <a:ext cx="14223492" cy="1413662"/>
           </a:xfrm>
           <a:prstGeom prst="rect">
             <a:avLst/>
@@ -8433,13 +9364,13 @@
       </p:sp>
       <p:sp>
         <p:nvSpPr>
-          <p:cNvPr id="138" name="Rectangle 137"/>
+          <p:cNvPr id="161" name="Rectangle 160"/>
           <p:cNvSpPr/>
           <p:nvPr/>
         </p:nvSpPr>
         <p:spPr>
           <a:xfrm>
-            <a:off x="15585948" y="16328440"/>
+            <a:off x="15585948" y="21046744"/>
             <a:ext cx="347472" cy="347472"/>
           </a:xfrm>
           <a:prstGeom prst="rect">
@@ -8476,13 +9407,13 @@
       </p:sp>
       <p:sp>
         <p:nvSpPr>
-          <p:cNvPr id="139" name="TextBox 138"/>
+          <p:cNvPr id="162" name="TextBox 161"/>
           <p:cNvSpPr txBox="1"/>
           <p:nvPr/>
         </p:nvSpPr>
         <p:spPr>
           <a:xfrm>
-            <a:off x="15585948" y="16328440"/>
+            <a:off x="15585948" y="21046744"/>
             <a:ext cx="347472" cy="347472"/>
           </a:xfrm>
           <a:prstGeom prst="rect">
@@ -8511,14 +9442,14 @@
       </p:sp>
       <p:sp>
         <p:nvSpPr>
-          <p:cNvPr id="140" name="TextBox 139"/>
+          <p:cNvPr id="163" name="TextBox 162"/>
           <p:cNvSpPr txBox="1"/>
           <p:nvPr/>
         </p:nvSpPr>
         <p:spPr>
           <a:xfrm>
-            <a:off x="16116300" y="15868497"/>
-            <a:ext cx="13455396" cy="623986"/>
+            <a:off x="16116300" y="20641665"/>
+            <a:ext cx="13455396" cy="580095"/>
           </a:xfrm>
           <a:prstGeom prst="rect">
             <a:avLst/>
@@ -8546,14 +9477,14 @@
       </p:sp>
       <p:sp>
         <p:nvSpPr>
-          <p:cNvPr id="141" name="TextBox 140"/>
+          <p:cNvPr id="164" name="TextBox 163"/>
           <p:cNvSpPr txBox="1"/>
           <p:nvPr/>
         </p:nvSpPr>
         <p:spPr>
           <a:xfrm>
-            <a:off x="16116300" y="16437620"/>
-            <a:ext cx="13455396" cy="935979"/>
+            <a:off x="16116300" y="21166896"/>
+            <a:ext cx="13455396" cy="870143"/>
           </a:xfrm>
           <a:prstGeom prst="rect">
             <a:avLst/>
@@ -8574,20 +9505,20 @@
                 </a:solidFill>
                 <a:latin typeface="Calibri"/>
               </a:rPr>
-              <a:t>Run fully offline with no external API keys; keep third-party dependencies minimal, auditable and easy to install.</a:t>
-            </a:r>
-          </a:p>
-        </p:txBody>
-      </p:sp>
-      <p:sp>
-        <p:nvSpPr>
-          <p:cNvPr id="142" name="Rectangle 141"/>
+              <a:t>Run fully offline with no external API keys; keep third-party dependencies minimal and auditable.</a:t>
+            </a:r>
+          </a:p>
+        </p:txBody>
+      </p:sp>
+      <p:sp>
+        <p:nvSpPr>
+          <p:cNvPr id="165" name="Rectangle 164"/>
           <p:cNvSpPr/>
           <p:nvPr/>
         </p:nvSpPr>
         <p:spPr>
           <a:xfrm>
-            <a:off x="15476220" y="17346168"/>
+            <a:off x="15476220" y="22009607"/>
             <a:ext cx="14150340" cy="18288"/>
           </a:xfrm>
           <a:prstGeom prst="rect">
@@ -8624,14 +9555,14 @@
       </p:sp>
       <p:sp>
         <p:nvSpPr>
-          <p:cNvPr id="143" name="Rectangle 142"/>
+          <p:cNvPr id="166" name="Rectangle 165"/>
           <p:cNvSpPr/>
           <p:nvPr/>
         </p:nvSpPr>
         <p:spPr>
           <a:xfrm>
-            <a:off x="15412212" y="17931384"/>
-            <a:ext cx="14442948" cy="23353776"/>
+            <a:off x="15412212" y="22594824"/>
+            <a:ext cx="14442948" cy="18690336"/>
           </a:xfrm>
           <a:prstGeom prst="rect">
             <a:avLst/>
@@ -8667,14 +9598,14 @@
       </p:sp>
       <p:sp>
         <p:nvSpPr>
-          <p:cNvPr id="144" name="Rectangle 143"/>
+          <p:cNvPr id="167" name="Rectangle 166"/>
           <p:cNvSpPr/>
           <p:nvPr/>
         </p:nvSpPr>
         <p:spPr>
           <a:xfrm>
-            <a:off x="15329916" y="17849088"/>
-            <a:ext cx="14442948" cy="23353776"/>
+            <a:off x="15329916" y="22512528"/>
+            <a:ext cx="14442948" cy="18690336"/>
           </a:xfrm>
           <a:prstGeom prst="rect">
             <a:avLst/>
@@ -8712,13 +9643,13 @@
       </p:sp>
       <p:sp>
         <p:nvSpPr>
-          <p:cNvPr id="145" name="Rectangle 144"/>
+          <p:cNvPr id="168" name="Rectangle 167"/>
           <p:cNvSpPr/>
           <p:nvPr/>
         </p:nvSpPr>
         <p:spPr>
           <a:xfrm>
-            <a:off x="15329916" y="17849088"/>
+            <a:off x="15329916" y="22512528"/>
             <a:ext cx="14442948" cy="777240"/>
           </a:xfrm>
           <a:prstGeom prst="rect">
@@ -8755,14 +9686,14 @@
       </p:sp>
       <p:sp>
         <p:nvSpPr>
-          <p:cNvPr id="146" name="Rectangle 145"/>
+          <p:cNvPr id="169" name="Rectangle 168"/>
           <p:cNvSpPr/>
           <p:nvPr/>
         </p:nvSpPr>
         <p:spPr>
           <a:xfrm>
-            <a:off x="15329916" y="18626328"/>
-            <a:ext cx="91440" cy="22576536"/>
+            <a:off x="15329916" y="23289768"/>
+            <a:ext cx="91440" cy="17913096"/>
           </a:xfrm>
           <a:prstGeom prst="rect">
             <a:avLst/>
@@ -8798,13 +9729,13 @@
       </p:sp>
       <p:sp>
         <p:nvSpPr>
-          <p:cNvPr id="147" name="TextBox 146"/>
+          <p:cNvPr id="170" name="TextBox 169"/>
           <p:cNvSpPr txBox="1"/>
           <p:nvPr/>
         </p:nvSpPr>
         <p:spPr>
           <a:xfrm>
-            <a:off x="15531084" y="17922240"/>
+            <a:off x="15531084" y="22585680"/>
             <a:ext cx="14122908" cy="722376"/>
           </a:xfrm>
           <a:prstGeom prst="rect">
@@ -8833,13 +9764,13 @@
       </p:sp>
       <p:sp>
         <p:nvSpPr>
-          <p:cNvPr id="148" name="TextBox 147"/>
+          <p:cNvPr id="171" name="TextBox 170"/>
           <p:cNvSpPr txBox="1"/>
           <p:nvPr/>
         </p:nvSpPr>
         <p:spPr>
           <a:xfrm>
-            <a:off x="15531084" y="18653760"/>
+            <a:off x="15531084" y="23317200"/>
             <a:ext cx="914400" cy="502920"/>
           </a:xfrm>
           <a:prstGeom prst="rect">
@@ -8868,13 +9799,13 @@
       </p:sp>
       <p:sp>
         <p:nvSpPr>
-          <p:cNvPr id="149" name="TextBox 148"/>
+          <p:cNvPr id="172" name="TextBox 171"/>
           <p:cNvSpPr txBox="1"/>
           <p:nvPr/>
         </p:nvSpPr>
         <p:spPr>
           <a:xfrm>
-            <a:off x="16445484" y="18653760"/>
+            <a:off x="16445484" y="23317200"/>
             <a:ext cx="3200400" cy="502920"/>
           </a:xfrm>
           <a:prstGeom prst="rect">
@@ -8903,13 +9834,13 @@
       </p:sp>
       <p:sp>
         <p:nvSpPr>
-          <p:cNvPr id="150" name="TextBox 149"/>
+          <p:cNvPr id="173" name="TextBox 172"/>
           <p:cNvSpPr txBox="1"/>
           <p:nvPr/>
         </p:nvSpPr>
         <p:spPr>
           <a:xfrm>
-            <a:off x="20377404" y="18653760"/>
+            <a:off x="20377404" y="23317200"/>
             <a:ext cx="3200400" cy="502920"/>
           </a:xfrm>
           <a:prstGeom prst="rect">
@@ -8938,13 +9869,13 @@
       </p:sp>
       <p:sp>
         <p:nvSpPr>
-          <p:cNvPr id="151" name="TextBox 150"/>
+          <p:cNvPr id="174" name="TextBox 173"/>
           <p:cNvSpPr txBox="1"/>
           <p:nvPr/>
         </p:nvSpPr>
         <p:spPr>
           <a:xfrm>
-            <a:off x="23577804" y="18653760"/>
+            <a:off x="23577804" y="23317200"/>
             <a:ext cx="1828800" cy="502920"/>
           </a:xfrm>
           <a:prstGeom prst="rect">
@@ -8973,13 +9904,13 @@
       </p:sp>
       <p:sp>
         <p:nvSpPr>
-          <p:cNvPr id="152" name="TextBox 151"/>
+          <p:cNvPr id="175" name="TextBox 174"/>
           <p:cNvSpPr txBox="1"/>
           <p:nvPr/>
         </p:nvSpPr>
         <p:spPr>
           <a:xfrm>
-            <a:off x="25406604" y="18653760"/>
+            <a:off x="25406604" y="23317200"/>
             <a:ext cx="4160520" cy="502920"/>
           </a:xfrm>
           <a:prstGeom prst="rect">
@@ -9008,13 +9939,13 @@
       </p:sp>
       <p:sp>
         <p:nvSpPr>
-          <p:cNvPr id="153" name="Rectangle 152"/>
+          <p:cNvPr id="176" name="Rectangle 175"/>
           <p:cNvSpPr/>
           <p:nvPr/>
         </p:nvSpPr>
         <p:spPr>
           <a:xfrm>
-            <a:off x="15531084" y="19165824"/>
+            <a:off x="15531084" y="23829264"/>
             <a:ext cx="14040612" cy="36576"/>
           </a:xfrm>
           <a:prstGeom prst="rect">
@@ -9051,14 +9982,14 @@
       </p:sp>
       <p:sp>
         <p:nvSpPr>
-          <p:cNvPr id="154" name="Rectangle 153"/>
+          <p:cNvPr id="177" name="Rectangle 176"/>
           <p:cNvSpPr/>
           <p:nvPr/>
         </p:nvSpPr>
         <p:spPr>
           <a:xfrm>
-            <a:off x="15531084" y="19220688"/>
-            <a:ext cx="14040612" cy="7174992"/>
+            <a:off x="15531084" y="23884128"/>
+            <a:ext cx="14040612" cy="5620512"/>
           </a:xfrm>
           <a:prstGeom prst="rect">
             <a:avLst/>
@@ -9094,13 +10025,13 @@
       </p:sp>
       <p:sp>
         <p:nvSpPr>
-          <p:cNvPr id="155" name="Rectangle 154"/>
+          <p:cNvPr id="178" name="Rectangle 177"/>
           <p:cNvSpPr/>
           <p:nvPr/>
         </p:nvSpPr>
         <p:spPr>
           <a:xfrm>
-            <a:off x="15393924" y="22213824"/>
+            <a:off x="15393924" y="26100024"/>
             <a:ext cx="1188720" cy="1188720"/>
           </a:xfrm>
           <a:prstGeom prst="rect">
@@ -9137,13 +10068,13 @@
       </p:sp>
       <p:sp>
         <p:nvSpPr>
-          <p:cNvPr id="156" name="TextBox 155"/>
+          <p:cNvPr id="179" name="TextBox 178"/>
           <p:cNvSpPr txBox="1"/>
           <p:nvPr/>
         </p:nvSpPr>
         <p:spPr>
           <a:xfrm>
-            <a:off x="15393924" y="22213824"/>
+            <a:off x="15393924" y="26100024"/>
             <a:ext cx="1188720" cy="1188720"/>
           </a:xfrm>
           <a:prstGeom prst="rect">
@@ -9172,13 +10103,13 @@
       </p:sp>
       <p:sp>
         <p:nvSpPr>
-          <p:cNvPr id="157" name="Rectangle 156"/>
+          <p:cNvPr id="180" name="Rectangle 179"/>
           <p:cNvSpPr/>
           <p:nvPr/>
         </p:nvSpPr>
         <p:spPr>
           <a:xfrm>
-            <a:off x="16582644" y="21665184"/>
+            <a:off x="16582644" y="25551384"/>
             <a:ext cx="2926080" cy="2286000"/>
           </a:xfrm>
           <a:prstGeom prst="rect">
@@ -9217,13 +10148,13 @@
       </p:sp>
       <p:sp>
         <p:nvSpPr>
-          <p:cNvPr id="158" name="TextBox 157"/>
+          <p:cNvPr id="181" name="TextBox 180"/>
           <p:cNvSpPr txBox="1"/>
           <p:nvPr/>
         </p:nvSpPr>
         <p:spPr>
           <a:xfrm>
-            <a:off x="16655796" y="21738336"/>
+            <a:off x="16655796" y="25624536"/>
             <a:ext cx="2779776" cy="475488"/>
           </a:xfrm>
           <a:prstGeom prst="rect">
@@ -9252,13 +10183,13 @@
       </p:sp>
       <p:sp>
         <p:nvSpPr>
-          <p:cNvPr id="159" name="TextBox 158"/>
+          <p:cNvPr id="182" name="TextBox 181"/>
           <p:cNvSpPr txBox="1"/>
           <p:nvPr/>
         </p:nvSpPr>
         <p:spPr>
           <a:xfrm>
-            <a:off x="16655796" y="22195536"/>
+            <a:off x="16655796" y="26081736"/>
             <a:ext cx="2779776" cy="585216"/>
           </a:xfrm>
           <a:prstGeom prst="rect">
@@ -9287,13 +10218,13 @@
       </p:sp>
       <p:sp>
         <p:nvSpPr>
-          <p:cNvPr id="160" name="Rectangle 159"/>
+          <p:cNvPr id="183" name="Rectangle 182"/>
           <p:cNvSpPr/>
           <p:nvPr/>
         </p:nvSpPr>
         <p:spPr>
           <a:xfrm>
-            <a:off x="16719804" y="22872192"/>
+            <a:off x="16719804" y="26758392"/>
             <a:ext cx="2121408" cy="100584"/>
           </a:xfrm>
           <a:prstGeom prst="rect">
@@ -9330,13 +10261,13 @@
       </p:sp>
       <p:sp>
         <p:nvSpPr>
-          <p:cNvPr id="161" name="Rectangle 160"/>
+          <p:cNvPr id="184" name="Rectangle 183"/>
           <p:cNvSpPr/>
           <p:nvPr/>
         </p:nvSpPr>
         <p:spPr>
           <a:xfrm>
-            <a:off x="16719804" y="23091648"/>
+            <a:off x="16719804" y="26977848"/>
             <a:ext cx="1803196" cy="100584"/>
           </a:xfrm>
           <a:prstGeom prst="rect">
@@ -9373,13 +10304,13 @@
       </p:sp>
       <p:sp>
         <p:nvSpPr>
-          <p:cNvPr id="162" name="Rectangle 161"/>
+          <p:cNvPr id="185" name="Rectangle 184"/>
           <p:cNvSpPr/>
           <p:nvPr/>
         </p:nvSpPr>
         <p:spPr>
           <a:xfrm>
-            <a:off x="16719804" y="23311104"/>
+            <a:off x="16719804" y="27197304"/>
             <a:ext cx="1484985" cy="100584"/>
           </a:xfrm>
           <a:prstGeom prst="rect">
@@ -9416,13 +10347,13 @@
       </p:sp>
       <p:sp>
         <p:nvSpPr>
-          <p:cNvPr id="163" name="Rectangle 162"/>
+          <p:cNvPr id="186" name="Rectangle 185"/>
           <p:cNvSpPr/>
           <p:nvPr/>
         </p:nvSpPr>
         <p:spPr>
           <a:xfrm>
-            <a:off x="16719804" y="23530560"/>
+            <a:off x="16719804" y="27416760"/>
             <a:ext cx="1166774" cy="100584"/>
           </a:xfrm>
           <a:prstGeom prst="rect">
@@ -9459,13 +10390,13 @@
       </p:sp>
       <p:sp>
         <p:nvSpPr>
-          <p:cNvPr id="164" name="TextBox 163"/>
+          <p:cNvPr id="187" name="TextBox 186"/>
           <p:cNvSpPr txBox="1"/>
           <p:nvPr/>
         </p:nvSpPr>
         <p:spPr>
           <a:xfrm>
-            <a:off x="19645884" y="22259544"/>
+            <a:off x="19645884" y="26145744"/>
             <a:ext cx="731520" cy="1097280"/>
           </a:xfrm>
           <a:prstGeom prst="rect">
@@ -9494,13 +10425,13 @@
       </p:sp>
       <p:sp>
         <p:nvSpPr>
-          <p:cNvPr id="165" name="Rectangle 164"/>
+          <p:cNvPr id="188" name="Rectangle 187"/>
           <p:cNvSpPr/>
           <p:nvPr/>
         </p:nvSpPr>
         <p:spPr>
           <a:xfrm>
-            <a:off x="20514564" y="22259544"/>
+            <a:off x="20514564" y="26145744"/>
             <a:ext cx="2926080" cy="1097280"/>
           </a:xfrm>
           <a:prstGeom prst="rect">
@@ -9539,13 +10470,13 @@
       </p:sp>
       <p:sp>
         <p:nvSpPr>
-          <p:cNvPr id="166" name="TextBox 165"/>
+          <p:cNvPr id="189" name="TextBox 188"/>
           <p:cNvSpPr txBox="1"/>
           <p:nvPr/>
         </p:nvSpPr>
         <p:spPr>
           <a:xfrm>
-            <a:off x="20587716" y="22332696"/>
+            <a:off x="20587716" y="26218896"/>
             <a:ext cx="2779776" cy="438912"/>
           </a:xfrm>
           <a:prstGeom prst="rect">
@@ -9574,13 +10505,13 @@
       </p:sp>
       <p:sp>
         <p:nvSpPr>
-          <p:cNvPr id="167" name="TextBox 166"/>
+          <p:cNvPr id="190" name="TextBox 189"/>
           <p:cNvSpPr txBox="1"/>
           <p:nvPr/>
         </p:nvSpPr>
         <p:spPr>
           <a:xfrm>
-            <a:off x="20587716" y="22753320"/>
+            <a:off x="20587716" y="26639520"/>
             <a:ext cx="2779776" cy="548640"/>
           </a:xfrm>
           <a:prstGeom prst="rect">
@@ -9609,13 +10540,13 @@
       </p:sp>
       <p:sp>
         <p:nvSpPr>
-          <p:cNvPr id="168" name="Rectangle 167"/>
+          <p:cNvPr id="191" name="Rectangle 190"/>
           <p:cNvSpPr/>
           <p:nvPr/>
         </p:nvSpPr>
         <p:spPr>
           <a:xfrm>
-            <a:off x="23669244" y="22168104"/>
+            <a:off x="23669244" y="26054304"/>
             <a:ext cx="1645920" cy="1280160"/>
           </a:xfrm>
           <a:prstGeom prst="rect">
@@ -9652,13 +10583,13 @@
       </p:sp>
       <p:sp>
         <p:nvSpPr>
-          <p:cNvPr id="169" name="TextBox 168"/>
+          <p:cNvPr id="192" name="TextBox 191"/>
           <p:cNvSpPr txBox="1"/>
           <p:nvPr/>
         </p:nvSpPr>
         <p:spPr>
           <a:xfrm>
-            <a:off x="23669244" y="22213824"/>
+            <a:off x="23669244" y="26100024"/>
             <a:ext cx="1645920" cy="704088"/>
           </a:xfrm>
           <a:prstGeom prst="rect">
@@ -9687,13 +10618,13 @@
       </p:sp>
       <p:sp>
         <p:nvSpPr>
-          <p:cNvPr id="170" name="TextBox 169"/>
+          <p:cNvPr id="193" name="TextBox 192"/>
           <p:cNvSpPr txBox="1"/>
           <p:nvPr/>
         </p:nvSpPr>
         <p:spPr>
           <a:xfrm>
-            <a:off x="23669244" y="22910596"/>
+            <a:off x="23669244" y="26796796"/>
             <a:ext cx="1645920" cy="486460"/>
           </a:xfrm>
           <a:prstGeom prst="rect">
@@ -9722,13 +10653,13 @@
       </p:sp>
       <p:sp>
         <p:nvSpPr>
-          <p:cNvPr id="171" name="Rectangle 170"/>
+          <p:cNvPr id="194" name="Rectangle 193"/>
           <p:cNvSpPr/>
           <p:nvPr/>
         </p:nvSpPr>
         <p:spPr>
           <a:xfrm>
-            <a:off x="25498044" y="22488144"/>
+            <a:off x="25498044" y="26374344"/>
             <a:ext cx="3977640" cy="384048"/>
           </a:xfrm>
           <a:prstGeom prst="rect">
@@ -9765,13 +10696,13 @@
       </p:sp>
       <p:sp>
         <p:nvSpPr>
-          <p:cNvPr id="172" name="Rectangle 171"/>
+          <p:cNvPr id="195" name="Rectangle 194"/>
           <p:cNvSpPr/>
           <p:nvPr/>
         </p:nvSpPr>
         <p:spPr>
           <a:xfrm>
-            <a:off x="25498044" y="22488144"/>
+            <a:off x="25498044" y="26374344"/>
             <a:ext cx="3142335" cy="384048"/>
           </a:xfrm>
           <a:prstGeom prst="rect">
@@ -9808,13 +10739,13 @@
       </p:sp>
       <p:sp>
         <p:nvSpPr>
-          <p:cNvPr id="173" name="TextBox 172"/>
+          <p:cNvPr id="196" name="TextBox 195"/>
           <p:cNvSpPr txBox="1"/>
           <p:nvPr/>
         </p:nvSpPr>
         <p:spPr>
           <a:xfrm>
-            <a:off x="25498044" y="22012656"/>
+            <a:off x="25498044" y="25898856"/>
             <a:ext cx="3977640" cy="402336"/>
           </a:xfrm>
           <a:prstGeom prst="rect">
@@ -9843,13 +10774,13 @@
       </p:sp>
       <p:sp>
         <p:nvSpPr>
-          <p:cNvPr id="174" name="TextBox 173"/>
+          <p:cNvPr id="197" name="TextBox 196"/>
           <p:cNvSpPr txBox="1"/>
           <p:nvPr/>
         </p:nvSpPr>
         <p:spPr>
           <a:xfrm>
-            <a:off x="25498044" y="22927056"/>
+            <a:off x="25498044" y="26813256"/>
             <a:ext cx="3977640" cy="347472"/>
           </a:xfrm>
           <a:prstGeom prst="rect">
@@ -9871,21 +10802,21 @@
                 </a:solidFill>
                 <a:latin typeface="Calibri"/>
               </a:rPr>
-              <a:t>0%                                        100%</a:t>
-            </a:r>
-          </a:p>
-        </p:txBody>
-      </p:sp>
-      <p:sp>
-        <p:nvSpPr>
-          <p:cNvPr id="175" name="Rectangle 174"/>
+              <a:t>0%                                                            100%</a:t>
+            </a:r>
+          </a:p>
+        </p:txBody>
+      </p:sp>
+      <p:sp>
+        <p:nvSpPr>
+          <p:cNvPr id="198" name="Rectangle 197"/>
           <p:cNvSpPr/>
           <p:nvPr/>
         </p:nvSpPr>
         <p:spPr>
           <a:xfrm>
-            <a:off x="15531084" y="26487120"/>
-            <a:ext cx="14040612" cy="7174992"/>
+            <a:off x="15531084" y="29596080"/>
+            <a:ext cx="14040612" cy="5620512"/>
           </a:xfrm>
           <a:prstGeom prst="rect">
             <a:avLst/>
@@ -9921,13 +10852,13 @@
       </p:sp>
       <p:sp>
         <p:nvSpPr>
-          <p:cNvPr id="176" name="Rectangle 175"/>
+          <p:cNvPr id="199" name="Rectangle 198"/>
           <p:cNvSpPr/>
           <p:nvPr/>
         </p:nvSpPr>
         <p:spPr>
           <a:xfrm>
-            <a:off x="15393924" y="29480256"/>
+            <a:off x="15393924" y="31811976"/>
             <a:ext cx="1188720" cy="1188720"/>
           </a:xfrm>
           <a:prstGeom prst="rect">
@@ -9964,13 +10895,13 @@
       </p:sp>
       <p:sp>
         <p:nvSpPr>
-          <p:cNvPr id="177" name="TextBox 176"/>
+          <p:cNvPr id="200" name="TextBox 199"/>
           <p:cNvSpPr txBox="1"/>
           <p:nvPr/>
         </p:nvSpPr>
         <p:spPr>
           <a:xfrm>
-            <a:off x="15393924" y="29480256"/>
+            <a:off x="15393924" y="31811976"/>
             <a:ext cx="1188720" cy="1188720"/>
           </a:xfrm>
           <a:prstGeom prst="rect">
@@ -9999,13 +10930,13 @@
       </p:sp>
       <p:sp>
         <p:nvSpPr>
-          <p:cNvPr id="178" name="Rectangle 177"/>
+          <p:cNvPr id="201" name="Rectangle 200"/>
           <p:cNvSpPr/>
           <p:nvPr/>
         </p:nvSpPr>
         <p:spPr>
           <a:xfrm>
-            <a:off x="16582644" y="28931616"/>
+            <a:off x="16582644" y="31263336"/>
             <a:ext cx="2926080" cy="2286000"/>
           </a:xfrm>
           <a:prstGeom prst="rect">
@@ -10044,13 +10975,13 @@
       </p:sp>
       <p:sp>
         <p:nvSpPr>
-          <p:cNvPr id="179" name="TextBox 178"/>
+          <p:cNvPr id="202" name="TextBox 201"/>
           <p:cNvSpPr txBox="1"/>
           <p:nvPr/>
         </p:nvSpPr>
         <p:spPr>
           <a:xfrm>
-            <a:off x="16655796" y="29004768"/>
+            <a:off x="16655796" y="31336488"/>
             <a:ext cx="2779776" cy="475488"/>
           </a:xfrm>
           <a:prstGeom prst="rect">
@@ -10079,13 +11010,13 @@
       </p:sp>
       <p:sp>
         <p:nvSpPr>
-          <p:cNvPr id="180" name="TextBox 179"/>
+          <p:cNvPr id="203" name="TextBox 202"/>
           <p:cNvSpPr txBox="1"/>
           <p:nvPr/>
         </p:nvSpPr>
         <p:spPr>
           <a:xfrm>
-            <a:off x="16655796" y="29461968"/>
+            <a:off x="16655796" y="31793688"/>
             <a:ext cx="2779776" cy="585216"/>
           </a:xfrm>
           <a:prstGeom prst="rect">
@@ -10114,13 +11045,13 @@
       </p:sp>
       <p:sp>
         <p:nvSpPr>
-          <p:cNvPr id="181" name="Rectangle 180"/>
+          <p:cNvPr id="204" name="Rectangle 203"/>
           <p:cNvSpPr/>
           <p:nvPr/>
         </p:nvSpPr>
         <p:spPr>
           <a:xfrm>
-            <a:off x="16719804" y="30138624"/>
+            <a:off x="16719804" y="32470344"/>
             <a:ext cx="2121408" cy="100584"/>
           </a:xfrm>
           <a:prstGeom prst="rect">
@@ -10157,13 +11088,13 @@
       </p:sp>
       <p:sp>
         <p:nvSpPr>
-          <p:cNvPr id="182" name="Rectangle 181"/>
+          <p:cNvPr id="205" name="Rectangle 204"/>
           <p:cNvSpPr/>
           <p:nvPr/>
         </p:nvSpPr>
         <p:spPr>
           <a:xfrm>
-            <a:off x="16719804" y="30358080"/>
+            <a:off x="16719804" y="32689800"/>
             <a:ext cx="1803196" cy="100584"/>
           </a:xfrm>
           <a:prstGeom prst="rect">
@@ -10200,13 +11131,13 @@
       </p:sp>
       <p:sp>
         <p:nvSpPr>
-          <p:cNvPr id="183" name="Rectangle 182"/>
+          <p:cNvPr id="206" name="Rectangle 205"/>
           <p:cNvSpPr/>
           <p:nvPr/>
         </p:nvSpPr>
         <p:spPr>
           <a:xfrm>
-            <a:off x="16719804" y="30577536"/>
+            <a:off x="16719804" y="32909256"/>
             <a:ext cx="1484985" cy="100584"/>
           </a:xfrm>
           <a:prstGeom prst="rect">
@@ -10243,13 +11174,13 @@
       </p:sp>
       <p:sp>
         <p:nvSpPr>
-          <p:cNvPr id="184" name="Rectangle 183"/>
+          <p:cNvPr id="207" name="Rectangle 206"/>
           <p:cNvSpPr/>
           <p:nvPr/>
         </p:nvSpPr>
         <p:spPr>
           <a:xfrm>
-            <a:off x="16719804" y="30796992"/>
+            <a:off x="16719804" y="33128712"/>
             <a:ext cx="1166774" cy="100584"/>
           </a:xfrm>
           <a:prstGeom prst="rect">
@@ -10286,13 +11217,13 @@
       </p:sp>
       <p:sp>
         <p:nvSpPr>
-          <p:cNvPr id="185" name="TextBox 184"/>
+          <p:cNvPr id="208" name="TextBox 207"/>
           <p:cNvSpPr txBox="1"/>
           <p:nvPr/>
         </p:nvSpPr>
         <p:spPr>
           <a:xfrm>
-            <a:off x="19645884" y="29525976"/>
+            <a:off x="19645884" y="31857696"/>
             <a:ext cx="731520" cy="1097280"/>
           </a:xfrm>
           <a:prstGeom prst="rect">
@@ -10321,13 +11252,13 @@
       </p:sp>
       <p:sp>
         <p:nvSpPr>
-          <p:cNvPr id="186" name="Rectangle 185"/>
+          <p:cNvPr id="209" name="Rectangle 208"/>
           <p:cNvSpPr/>
           <p:nvPr/>
         </p:nvSpPr>
         <p:spPr>
           <a:xfrm>
-            <a:off x="20514564" y="29525976"/>
+            <a:off x="20514564" y="31857696"/>
             <a:ext cx="2926080" cy="1097280"/>
           </a:xfrm>
           <a:prstGeom prst="rect">
@@ -10366,13 +11297,13 @@
       </p:sp>
       <p:sp>
         <p:nvSpPr>
-          <p:cNvPr id="187" name="TextBox 186"/>
+          <p:cNvPr id="210" name="TextBox 209"/>
           <p:cNvSpPr txBox="1"/>
           <p:nvPr/>
         </p:nvSpPr>
         <p:spPr>
           <a:xfrm>
-            <a:off x="20587716" y="29599128"/>
+            <a:off x="20587716" y="31930848"/>
             <a:ext cx="2779776" cy="438912"/>
           </a:xfrm>
           <a:prstGeom prst="rect">
@@ -10401,13 +11332,13 @@
       </p:sp>
       <p:sp>
         <p:nvSpPr>
-          <p:cNvPr id="188" name="TextBox 187"/>
+          <p:cNvPr id="211" name="TextBox 210"/>
           <p:cNvSpPr txBox="1"/>
           <p:nvPr/>
         </p:nvSpPr>
         <p:spPr>
           <a:xfrm>
-            <a:off x="20587716" y="30019752"/>
+            <a:off x="20587716" y="32351472"/>
             <a:ext cx="2779776" cy="548640"/>
           </a:xfrm>
           <a:prstGeom prst="rect">
@@ -10436,13 +11367,13 @@
       </p:sp>
       <p:sp>
         <p:nvSpPr>
-          <p:cNvPr id="189" name="Rectangle 188"/>
+          <p:cNvPr id="212" name="Rectangle 211"/>
           <p:cNvSpPr/>
           <p:nvPr/>
         </p:nvSpPr>
         <p:spPr>
           <a:xfrm>
-            <a:off x="23669244" y="29434536"/>
+            <a:off x="23669244" y="31766256"/>
             <a:ext cx="1645920" cy="1280160"/>
           </a:xfrm>
           <a:prstGeom prst="rect">
@@ -10479,13 +11410,13 @@
       </p:sp>
       <p:sp>
         <p:nvSpPr>
-          <p:cNvPr id="190" name="TextBox 189"/>
+          <p:cNvPr id="213" name="TextBox 212"/>
           <p:cNvSpPr txBox="1"/>
           <p:nvPr/>
         </p:nvSpPr>
         <p:spPr>
           <a:xfrm>
-            <a:off x="23669244" y="29480256"/>
+            <a:off x="23669244" y="31811976"/>
             <a:ext cx="1645920" cy="704088"/>
           </a:xfrm>
           <a:prstGeom prst="rect">
@@ -10514,13 +11445,13 @@
       </p:sp>
       <p:sp>
         <p:nvSpPr>
-          <p:cNvPr id="191" name="TextBox 190"/>
+          <p:cNvPr id="214" name="TextBox 213"/>
           <p:cNvSpPr txBox="1"/>
           <p:nvPr/>
         </p:nvSpPr>
         <p:spPr>
           <a:xfrm>
-            <a:off x="23669244" y="30177028"/>
+            <a:off x="23669244" y="32508748"/>
             <a:ext cx="1645920" cy="486460"/>
           </a:xfrm>
           <a:prstGeom prst="rect">
@@ -10549,13 +11480,13 @@
       </p:sp>
       <p:sp>
         <p:nvSpPr>
-          <p:cNvPr id="192" name="Rectangle 191"/>
+          <p:cNvPr id="215" name="Rectangle 214"/>
           <p:cNvSpPr/>
           <p:nvPr/>
         </p:nvSpPr>
         <p:spPr>
           <a:xfrm>
-            <a:off x="25498044" y="29754576"/>
+            <a:off x="25498044" y="32086296"/>
             <a:ext cx="3977640" cy="384048"/>
           </a:xfrm>
           <a:prstGeom prst="rect">
@@ -10592,13 +11523,13 @@
       </p:sp>
       <p:sp>
         <p:nvSpPr>
-          <p:cNvPr id="193" name="Rectangle 192"/>
+          <p:cNvPr id="216" name="Rectangle 215"/>
           <p:cNvSpPr/>
           <p:nvPr/>
         </p:nvSpPr>
         <p:spPr>
           <a:xfrm>
-            <a:off x="25498044" y="29754576"/>
+            <a:off x="25498044" y="32086296"/>
             <a:ext cx="2585466" cy="384048"/>
           </a:xfrm>
           <a:prstGeom prst="rect">
@@ -10635,13 +11566,13 @@
       </p:sp>
       <p:sp>
         <p:nvSpPr>
-          <p:cNvPr id="194" name="TextBox 193"/>
+          <p:cNvPr id="217" name="TextBox 216"/>
           <p:cNvSpPr txBox="1"/>
           <p:nvPr/>
         </p:nvSpPr>
         <p:spPr>
           <a:xfrm>
-            <a:off x="25498044" y="29279088"/>
+            <a:off x="25498044" y="31610808"/>
             <a:ext cx="3977640" cy="402336"/>
           </a:xfrm>
           <a:prstGeom prst="rect">
@@ -10670,13 +11601,13 @@
       </p:sp>
       <p:sp>
         <p:nvSpPr>
-          <p:cNvPr id="195" name="TextBox 194"/>
+          <p:cNvPr id="218" name="TextBox 217"/>
           <p:cNvSpPr txBox="1"/>
           <p:nvPr/>
         </p:nvSpPr>
         <p:spPr>
           <a:xfrm>
-            <a:off x="25498044" y="30193488"/>
+            <a:off x="25498044" y="32525208"/>
             <a:ext cx="3977640" cy="347472"/>
           </a:xfrm>
           <a:prstGeom prst="rect">
@@ -10698,21 +11629,21 @@
                 </a:solidFill>
                 <a:latin typeface="Calibri"/>
               </a:rPr>
-              <a:t>0%                                        100%</a:t>
-            </a:r>
-          </a:p>
-        </p:txBody>
-      </p:sp>
-      <p:sp>
-        <p:nvSpPr>
-          <p:cNvPr id="196" name="Rectangle 195"/>
+              <a:t>0%                                                            100%</a:t>
+            </a:r>
+          </a:p>
+        </p:txBody>
+      </p:sp>
+      <p:sp>
+        <p:nvSpPr>
+          <p:cNvPr id="219" name="Rectangle 218"/>
           <p:cNvSpPr/>
           <p:nvPr/>
         </p:nvSpPr>
         <p:spPr>
           <a:xfrm>
-            <a:off x="15531084" y="33753552"/>
-            <a:ext cx="14040612" cy="7174992"/>
+            <a:off x="15531084" y="35308032"/>
+            <a:ext cx="14040612" cy="5620512"/>
           </a:xfrm>
           <a:prstGeom prst="rect">
             <a:avLst/>
@@ -10748,13 +11679,13 @@
       </p:sp>
       <p:sp>
         <p:nvSpPr>
-          <p:cNvPr id="197" name="Rectangle 196"/>
+          <p:cNvPr id="220" name="Rectangle 219"/>
           <p:cNvSpPr/>
           <p:nvPr/>
         </p:nvSpPr>
         <p:spPr>
           <a:xfrm>
-            <a:off x="15393924" y="36746688"/>
+            <a:off x="15393924" y="37523928"/>
             <a:ext cx="1188720" cy="1188720"/>
           </a:xfrm>
           <a:prstGeom prst="rect">
@@ -10791,13 +11722,13 @@
       </p:sp>
       <p:sp>
         <p:nvSpPr>
-          <p:cNvPr id="198" name="TextBox 197"/>
+          <p:cNvPr id="221" name="TextBox 220"/>
           <p:cNvSpPr txBox="1"/>
           <p:nvPr/>
         </p:nvSpPr>
         <p:spPr>
           <a:xfrm>
-            <a:off x="15393924" y="36746688"/>
+            <a:off x="15393924" y="37523928"/>
             <a:ext cx="1188720" cy="1188720"/>
           </a:xfrm>
           <a:prstGeom prst="rect">
@@ -10826,13 +11757,13 @@
       </p:sp>
       <p:sp>
         <p:nvSpPr>
-          <p:cNvPr id="199" name="Rectangle 198"/>
+          <p:cNvPr id="222" name="Rectangle 221"/>
           <p:cNvSpPr/>
           <p:nvPr/>
         </p:nvSpPr>
         <p:spPr>
           <a:xfrm>
-            <a:off x="16582644" y="36198048"/>
+            <a:off x="16582644" y="36975288"/>
             <a:ext cx="2926080" cy="2286000"/>
           </a:xfrm>
           <a:prstGeom prst="rect">
@@ -10871,13 +11802,13 @@
       </p:sp>
       <p:sp>
         <p:nvSpPr>
-          <p:cNvPr id="200" name="TextBox 199"/>
+          <p:cNvPr id="223" name="TextBox 222"/>
           <p:cNvSpPr txBox="1"/>
           <p:nvPr/>
         </p:nvSpPr>
         <p:spPr>
           <a:xfrm>
-            <a:off x="16655796" y="36271200"/>
+            <a:off x="16655796" y="37048440"/>
             <a:ext cx="2779776" cy="475488"/>
           </a:xfrm>
           <a:prstGeom prst="rect">
@@ -10906,13 +11837,13 @@
       </p:sp>
       <p:sp>
         <p:nvSpPr>
-          <p:cNvPr id="201" name="TextBox 200"/>
+          <p:cNvPr id="224" name="TextBox 223"/>
           <p:cNvSpPr txBox="1"/>
           <p:nvPr/>
         </p:nvSpPr>
         <p:spPr>
           <a:xfrm>
-            <a:off x="16655796" y="36728400"/>
+            <a:off x="16655796" y="37505640"/>
             <a:ext cx="2779776" cy="585216"/>
           </a:xfrm>
           <a:prstGeom prst="rect">
@@ -10941,13 +11872,13 @@
       </p:sp>
       <p:sp>
         <p:nvSpPr>
-          <p:cNvPr id="202" name="Rectangle 201"/>
+          <p:cNvPr id="225" name="Rectangle 224"/>
           <p:cNvSpPr/>
           <p:nvPr/>
         </p:nvSpPr>
         <p:spPr>
           <a:xfrm>
-            <a:off x="16719804" y="37405056"/>
+            <a:off x="16719804" y="38182296"/>
             <a:ext cx="2121408" cy="100584"/>
           </a:xfrm>
           <a:prstGeom prst="rect">
@@ -10984,13 +11915,13 @@
       </p:sp>
       <p:sp>
         <p:nvSpPr>
-          <p:cNvPr id="203" name="Rectangle 202"/>
+          <p:cNvPr id="226" name="Rectangle 225"/>
           <p:cNvSpPr/>
           <p:nvPr/>
         </p:nvSpPr>
         <p:spPr>
           <a:xfrm>
-            <a:off x="16719804" y="37624512"/>
+            <a:off x="16719804" y="38401752"/>
             <a:ext cx="1803196" cy="100584"/>
           </a:xfrm>
           <a:prstGeom prst="rect">
@@ -11027,13 +11958,13 @@
       </p:sp>
       <p:sp>
         <p:nvSpPr>
-          <p:cNvPr id="204" name="Rectangle 203"/>
+          <p:cNvPr id="227" name="Rectangle 226"/>
           <p:cNvSpPr/>
           <p:nvPr/>
         </p:nvSpPr>
         <p:spPr>
           <a:xfrm>
-            <a:off x="16719804" y="37843968"/>
+            <a:off x="16719804" y="38621208"/>
             <a:ext cx="1484985" cy="100584"/>
           </a:xfrm>
           <a:prstGeom prst="rect">
@@ -11070,13 +12001,13 @@
       </p:sp>
       <p:sp>
         <p:nvSpPr>
-          <p:cNvPr id="205" name="Rectangle 204"/>
+          <p:cNvPr id="228" name="Rectangle 227"/>
           <p:cNvSpPr/>
           <p:nvPr/>
         </p:nvSpPr>
         <p:spPr>
           <a:xfrm>
-            <a:off x="16719804" y="38063424"/>
+            <a:off x="16719804" y="38840664"/>
             <a:ext cx="1166774" cy="100584"/>
           </a:xfrm>
           <a:prstGeom prst="rect">
@@ -11113,13 +12044,13 @@
       </p:sp>
       <p:sp>
         <p:nvSpPr>
-          <p:cNvPr id="206" name="TextBox 205"/>
+          <p:cNvPr id="229" name="TextBox 228"/>
           <p:cNvSpPr txBox="1"/>
           <p:nvPr/>
         </p:nvSpPr>
         <p:spPr>
           <a:xfrm>
-            <a:off x="19645884" y="36792408"/>
+            <a:off x="19645884" y="37569648"/>
             <a:ext cx="731520" cy="1097280"/>
           </a:xfrm>
           <a:prstGeom prst="rect">
@@ -11148,13 +12079,13 @@
       </p:sp>
       <p:sp>
         <p:nvSpPr>
-          <p:cNvPr id="207" name="Rectangle 206"/>
+          <p:cNvPr id="230" name="Rectangle 229"/>
           <p:cNvSpPr/>
           <p:nvPr/>
         </p:nvSpPr>
         <p:spPr>
           <a:xfrm>
-            <a:off x="20514564" y="36792408"/>
+            <a:off x="20514564" y="37569648"/>
             <a:ext cx="2926080" cy="1097280"/>
           </a:xfrm>
           <a:prstGeom prst="rect">
@@ -11193,13 +12124,13 @@
       </p:sp>
       <p:sp>
         <p:nvSpPr>
-          <p:cNvPr id="208" name="TextBox 207"/>
+          <p:cNvPr id="231" name="TextBox 230"/>
           <p:cNvSpPr txBox="1"/>
           <p:nvPr/>
         </p:nvSpPr>
         <p:spPr>
           <a:xfrm>
-            <a:off x="20587716" y="36865560"/>
+            <a:off x="20587716" y="37642800"/>
             <a:ext cx="2779776" cy="438912"/>
           </a:xfrm>
           <a:prstGeom prst="rect">
@@ -11228,13 +12159,13 @@
       </p:sp>
       <p:sp>
         <p:nvSpPr>
-          <p:cNvPr id="209" name="TextBox 208"/>
+          <p:cNvPr id="232" name="TextBox 231"/>
           <p:cNvSpPr txBox="1"/>
           <p:nvPr/>
         </p:nvSpPr>
         <p:spPr>
           <a:xfrm>
-            <a:off x="20587716" y="37286184"/>
+            <a:off x="20587716" y="38063424"/>
             <a:ext cx="2779776" cy="548640"/>
           </a:xfrm>
           <a:prstGeom prst="rect">
@@ -11263,13 +12194,13 @@
       </p:sp>
       <p:sp>
         <p:nvSpPr>
-          <p:cNvPr id="210" name="Rectangle 209"/>
+          <p:cNvPr id="233" name="Rectangle 232"/>
           <p:cNvSpPr/>
           <p:nvPr/>
         </p:nvSpPr>
         <p:spPr>
           <a:xfrm>
-            <a:off x="23669244" y="36700968"/>
+            <a:off x="23669244" y="37478208"/>
             <a:ext cx="1645920" cy="1280160"/>
           </a:xfrm>
           <a:prstGeom prst="rect">
@@ -11306,13 +12237,13 @@
       </p:sp>
       <p:sp>
         <p:nvSpPr>
-          <p:cNvPr id="211" name="TextBox 210"/>
+          <p:cNvPr id="234" name="TextBox 233"/>
           <p:cNvSpPr txBox="1"/>
           <p:nvPr/>
         </p:nvSpPr>
         <p:spPr>
           <a:xfrm>
-            <a:off x="23669244" y="36746688"/>
+            <a:off x="23669244" y="37523928"/>
             <a:ext cx="1645920" cy="704088"/>
           </a:xfrm>
           <a:prstGeom prst="rect">
@@ -11341,13 +12272,13 @@
       </p:sp>
       <p:sp>
         <p:nvSpPr>
-          <p:cNvPr id="212" name="TextBox 211"/>
+          <p:cNvPr id="235" name="TextBox 234"/>
           <p:cNvSpPr txBox="1"/>
           <p:nvPr/>
         </p:nvSpPr>
         <p:spPr>
           <a:xfrm>
-            <a:off x="23669244" y="37443460"/>
+            <a:off x="23669244" y="38220700"/>
             <a:ext cx="1645920" cy="486460"/>
           </a:xfrm>
           <a:prstGeom prst="rect">
@@ -11376,13 +12307,13 @@
       </p:sp>
       <p:sp>
         <p:nvSpPr>
-          <p:cNvPr id="213" name="Rectangle 212"/>
+          <p:cNvPr id="236" name="Rectangle 235"/>
           <p:cNvSpPr/>
           <p:nvPr/>
         </p:nvSpPr>
         <p:spPr>
           <a:xfrm>
-            <a:off x="25498044" y="37021008"/>
+            <a:off x="25498044" y="37798248"/>
             <a:ext cx="3977640" cy="384048"/>
           </a:xfrm>
           <a:prstGeom prst="rect">
@@ -11419,13 +12350,13 @@
       </p:sp>
       <p:sp>
         <p:nvSpPr>
-          <p:cNvPr id="214" name="Rectangle 213"/>
+          <p:cNvPr id="237" name="Rectangle 236"/>
           <p:cNvSpPr/>
           <p:nvPr/>
         </p:nvSpPr>
         <p:spPr>
           <a:xfrm>
-            <a:off x="25498044" y="37021008"/>
+            <a:off x="25498044" y="37798248"/>
             <a:ext cx="3062782" cy="384048"/>
           </a:xfrm>
           <a:prstGeom prst="rect">
@@ -11462,13 +12393,13 @@
       </p:sp>
       <p:sp>
         <p:nvSpPr>
-          <p:cNvPr id="215" name="TextBox 214"/>
+          <p:cNvPr id="238" name="TextBox 237"/>
           <p:cNvSpPr txBox="1"/>
           <p:nvPr/>
         </p:nvSpPr>
         <p:spPr>
           <a:xfrm>
-            <a:off x="25498044" y="36545520"/>
+            <a:off x="25498044" y="37322760"/>
             <a:ext cx="3977640" cy="402336"/>
           </a:xfrm>
           <a:prstGeom prst="rect">
@@ -11497,13 +12428,13 @@
       </p:sp>
       <p:sp>
         <p:nvSpPr>
-          <p:cNvPr id="216" name="TextBox 215"/>
+          <p:cNvPr id="239" name="TextBox 238"/>
           <p:cNvSpPr txBox="1"/>
           <p:nvPr/>
         </p:nvSpPr>
         <p:spPr>
           <a:xfrm>
-            <a:off x="25498044" y="37459920"/>
+            <a:off x="25498044" y="38237160"/>
             <a:ext cx="3977640" cy="347472"/>
           </a:xfrm>
           <a:prstGeom prst="rect">
@@ -11525,14 +12456,14 @@
                 </a:solidFill>
                 <a:latin typeface="Calibri"/>
               </a:rPr>
-              <a:t>0%                                        100%</a:t>
-            </a:r>
-          </a:p>
-        </p:txBody>
-      </p:sp>
-      <p:sp>
-        <p:nvSpPr>
-          <p:cNvPr id="217" name="Rectangle 216"/>
+              <a:t>0%                                                            100%</a:t>
+            </a:r>
+          </a:p>
+        </p:txBody>
+      </p:sp>
+      <p:sp>
+        <p:nvSpPr>
+          <p:cNvPr id="240" name="Rectangle 239"/>
           <p:cNvSpPr/>
           <p:nvPr/>
         </p:nvSpPr>
@@ -11575,7 +12506,7 @@
       </p:sp>
       <p:sp>
         <p:nvSpPr>
-          <p:cNvPr id="218" name="Rectangle 217"/>
+          <p:cNvPr id="241" name="Rectangle 240"/>
           <p:cNvSpPr/>
           <p:nvPr/>
         </p:nvSpPr>
@@ -11618,7 +12549,7 @@
       </p:sp>
       <p:sp>
         <p:nvSpPr>
-          <p:cNvPr id="219" name="Rectangle 218"/>
+          <p:cNvPr id="242" name="Rectangle 241"/>
           <p:cNvSpPr/>
           <p:nvPr/>
         </p:nvSpPr>
@@ -11661,7 +12592,7 @@
       </p:sp>
       <p:sp>
         <p:nvSpPr>
-          <p:cNvPr id="220" name="TextBox 219"/>
+          <p:cNvPr id="243" name="TextBox 242"/>
           <p:cNvSpPr txBox="1"/>
           <p:nvPr/>
         </p:nvSpPr>
@@ -11689,14 +12620,14 @@
                 </a:solidFill>
                 <a:latin typeface="Calibri"/>
               </a:rPr>
-              <a:t>DocCompressor  ·  BS Robotics &amp; Artificial Intelligence  ·  Instructor: Ms Eisha Nawaz</a:t>
-            </a:r>
-          </a:p>
-        </p:txBody>
-      </p:sp>
-      <p:sp>
-        <p:nvSpPr>
-          <p:cNvPr id="221" name="TextBox 220"/>
+              <a:t>DocCompressor  ·  BS Robotics &amp; Artificial Intelligence  ·  Mubashar Ali  |  Momina Ali</a:t>
+            </a:r>
+          </a:p>
+        </p:txBody>
+      </p:sp>
+      <p:sp>
+        <p:nvSpPr>
+          <p:cNvPr id="244" name="TextBox 243"/>
           <p:cNvSpPr txBox="1"/>
           <p:nvPr/>
         </p:nvSpPr>
@@ -11724,7 +12655,7 @@
                 </a:solidFill>
                 <a:latin typeface="Calibri"/>
               </a:rPr>
-              <a:t>Programming Fundamentals (PF)   |   © 2024  —  All rights reserved</a:t>
+              <a:t>Programming Fundamentals (PF)   ·   Instructor: Ms Eisha Nawaz   ·   © 2024</a:t>
             </a:r>
           </a:p>
         </p:txBody>

</xml_diff>